<commit_message>
data_view supports the .at() access to data entries or sub-views
</commit_message>
<xml_diff>
--- a/doc/big_picture.pptx
+++ b/doc/big_picture.pptx
@@ -210,7 +210,7 @@
           <a:p>
             <a:fld id="{0FF26850-8575-9945-A6DF-A0798D281566}" type="datetimeFigureOut">
               <a:rPr lang="de-DE" smtClean="0"/>
-              <a:t>18.06.24</a:t>
+              <a:t>11.03.26</a:t>
             </a:fld>
             <a:endParaRPr lang="de-DE"/>
           </a:p>
@@ -861,7 +861,7 @@
           <a:p>
             <a:fld id="{60A3E910-B59F-F444-BE29-3A643468020D}" type="datetimeFigureOut">
               <a:rPr lang="de-DE" smtClean="0"/>
-              <a:t>18.06.24</a:t>
+              <a:t>11.03.26</a:t>
             </a:fld>
             <a:endParaRPr lang="de-DE"/>
           </a:p>
@@ -1031,7 +1031,7 @@
           <a:p>
             <a:fld id="{60A3E910-B59F-F444-BE29-3A643468020D}" type="datetimeFigureOut">
               <a:rPr lang="de-DE" smtClean="0"/>
-              <a:t>18.06.24</a:t>
+              <a:t>11.03.26</a:t>
             </a:fld>
             <a:endParaRPr lang="de-DE"/>
           </a:p>
@@ -1211,7 +1211,7 @@
           <a:p>
             <a:fld id="{60A3E910-B59F-F444-BE29-3A643468020D}" type="datetimeFigureOut">
               <a:rPr lang="de-DE" smtClean="0"/>
-              <a:t>18.06.24</a:t>
+              <a:t>11.03.26</a:t>
             </a:fld>
             <a:endParaRPr lang="de-DE"/>
           </a:p>
@@ -1381,7 +1381,7 @@
           <a:p>
             <a:fld id="{60A3E910-B59F-F444-BE29-3A643468020D}" type="datetimeFigureOut">
               <a:rPr lang="de-DE" smtClean="0"/>
-              <a:t>18.06.24</a:t>
+              <a:t>11.03.26</a:t>
             </a:fld>
             <a:endParaRPr lang="de-DE"/>
           </a:p>
@@ -1625,7 +1625,7 @@
           <a:p>
             <a:fld id="{60A3E910-B59F-F444-BE29-3A643468020D}" type="datetimeFigureOut">
               <a:rPr lang="de-DE" smtClean="0"/>
-              <a:t>18.06.24</a:t>
+              <a:t>11.03.26</a:t>
             </a:fld>
             <a:endParaRPr lang="de-DE"/>
           </a:p>
@@ -1857,7 +1857,7 @@
           <a:p>
             <a:fld id="{60A3E910-B59F-F444-BE29-3A643468020D}" type="datetimeFigureOut">
               <a:rPr lang="de-DE" smtClean="0"/>
-              <a:t>18.06.24</a:t>
+              <a:t>11.03.26</a:t>
             </a:fld>
             <a:endParaRPr lang="de-DE"/>
           </a:p>
@@ -2224,7 +2224,7 @@
           <a:p>
             <a:fld id="{60A3E910-B59F-F444-BE29-3A643468020D}" type="datetimeFigureOut">
               <a:rPr lang="de-DE" smtClean="0"/>
-              <a:t>18.06.24</a:t>
+              <a:t>11.03.26</a:t>
             </a:fld>
             <a:endParaRPr lang="de-DE"/>
           </a:p>
@@ -2342,7 +2342,7 @@
           <a:p>
             <a:fld id="{60A3E910-B59F-F444-BE29-3A643468020D}" type="datetimeFigureOut">
               <a:rPr lang="de-DE" smtClean="0"/>
-              <a:t>18.06.24</a:t>
+              <a:t>11.03.26</a:t>
             </a:fld>
             <a:endParaRPr lang="de-DE"/>
           </a:p>
@@ -2437,7 +2437,7 @@
           <a:p>
             <a:fld id="{60A3E910-B59F-F444-BE29-3A643468020D}" type="datetimeFigureOut">
               <a:rPr lang="de-DE" smtClean="0"/>
-              <a:t>18.06.24</a:t>
+              <a:t>11.03.26</a:t>
             </a:fld>
             <a:endParaRPr lang="de-DE"/>
           </a:p>
@@ -2714,7 +2714,7 @@
           <a:p>
             <a:fld id="{60A3E910-B59F-F444-BE29-3A643468020D}" type="datetimeFigureOut">
               <a:rPr lang="de-DE" smtClean="0"/>
-              <a:t>18.06.24</a:t>
+              <a:t>11.03.26</a:t>
             </a:fld>
             <a:endParaRPr lang="de-DE"/>
           </a:p>
@@ -2971,7 +2971,7 @@
           <a:p>
             <a:fld id="{60A3E910-B59F-F444-BE29-3A643468020D}" type="datetimeFigureOut">
               <a:rPr lang="de-DE" smtClean="0"/>
-              <a:t>18.06.24</a:t>
+              <a:t>11.03.26</a:t>
             </a:fld>
             <a:endParaRPr lang="de-DE"/>
           </a:p>
@@ -3184,7 +3184,7 @@
           <a:p>
             <a:fld id="{60A3E910-B59F-F444-BE29-3A643468020D}" type="datetimeFigureOut">
               <a:rPr lang="de-DE" smtClean="0"/>
-              <a:t>18.06.24</a:t>
+              <a:t>11.03.26</a:t>
             </a:fld>
             <a:endParaRPr lang="de-DE"/>
           </a:p>
@@ -7580,7 +7580,7 @@
                 <a:latin typeface="Courier New" panose="02070309020205020404" pitchFamily="49" charset="0"/>
                 <a:cs typeface="Courier New" panose="02070309020205020404" pitchFamily="49" charset="0"/>
               </a:rPr>
-              <a:t>single</a:t>
+              <a:t>single_</a:t>
             </a:r>
             <a:br>
               <a:rPr lang="en-DE" dirty="0">
@@ -8174,9 +8174,9 @@
         <p:grpSpPr>
           <a:xfrm>
             <a:off x="11012850" y="2269495"/>
-            <a:ext cx="1736763" cy="812800"/>
+            <a:ext cx="1760553" cy="812800"/>
             <a:chOff x="1186778" y="672706"/>
-            <a:chExt cx="1736763" cy="812800"/>
+            <a:chExt cx="1760553" cy="812800"/>
           </a:xfrm>
         </p:grpSpPr>
         <p:pic>
@@ -8226,7 +8226,7 @@
           <p:spPr>
             <a:xfrm>
               <a:off x="1902108" y="910908"/>
-              <a:ext cx="1021433" cy="461665"/>
+              <a:ext cx="1045223" cy="461665"/>
             </a:xfrm>
             <a:prstGeom prst="rect">
               <a:avLst/>
@@ -8241,15 +8241,7 @@
             <a:p>
               <a:r>
                 <a:rPr lang="de-DE" sz="1200" dirty="0" err="1"/>
-                <a:t>input</a:t>
-              </a:r>
-              <a:r>
-                <a:rPr lang="de-DE" sz="1200" dirty="0"/>
-                <a:t> </a:t>
-              </a:r>
-              <a:r>
-                <a:rPr lang="de-DE" sz="1200" dirty="0" err="1"/>
-                <a:t>file</a:t>
+                <a:t>geometry.file</a:t>
               </a:r>
               <a:endParaRPr lang="de-DE" sz="1200" dirty="0"/>
             </a:p>
@@ -9721,15 +9713,15 @@
           </p:cNvPr>
           <p:cNvCxnSpPr>
             <a:cxnSpLocks/>
-            <a:stCxn id="14" idx="2"/>
-            <a:endCxn id="11" idx="0"/>
+            <a:stCxn id="14" idx="1"/>
+            <a:endCxn id="7" idx="3"/>
           </p:cNvCxnSpPr>
           <p:nvPr/>
         </p:nvCxnSpPr>
         <p:spPr>
-          <a:xfrm rot="16200000" flipH="1">
-            <a:off x="11255773" y="3245772"/>
-            <a:ext cx="337705" cy="10750"/>
+          <a:xfrm rot="10800000" flipV="1">
+            <a:off x="10146322" y="2675895"/>
+            <a:ext cx="866528" cy="68338"/>
           </a:xfrm>
           <a:prstGeom prst="bentConnector3">
             <a:avLst>
@@ -14210,6 +14202,51 @@
           </a:p>
         </p:txBody>
       </p:sp>
+      <p:cxnSp>
+        <p:nvCxnSpPr>
+          <p:cNvPr id="9" name="Elbow Connector 8">
+            <a:extLst>
+              <a:ext uri="{FF2B5EF4-FFF2-40B4-BE49-F238E27FC236}">
+                <a16:creationId xmlns:a16="http://schemas.microsoft.com/office/drawing/2014/main" id="{E4632847-6BC0-384C-5075-416406704D2A}"/>
+              </a:ext>
+            </a:extLst>
+          </p:cNvPr>
+          <p:cNvCxnSpPr>
+            <a:cxnSpLocks/>
+            <a:stCxn id="7" idx="2"/>
+            <a:endCxn id="11" idx="0"/>
+          </p:cNvCxnSpPr>
+          <p:nvPr/>
+        </p:nvCxnSpPr>
+        <p:spPr>
+          <a:xfrm rot="16200000" flipH="1">
+            <a:off x="10270278" y="2260277"/>
+            <a:ext cx="405767" cy="1913678"/>
+          </a:xfrm>
+          <a:prstGeom prst="bentConnector3">
+            <a:avLst>
+              <a:gd name="adj1" fmla="val 50000"/>
+            </a:avLst>
+          </a:prstGeom>
+          <a:ln>
+            <a:tailEnd type="triangle"/>
+          </a:ln>
+        </p:spPr>
+        <p:style>
+          <a:lnRef idx="1">
+            <a:schemeClr val="accent1"/>
+          </a:lnRef>
+          <a:fillRef idx="0">
+            <a:schemeClr val="accent1"/>
+          </a:fillRef>
+          <a:effectRef idx="0">
+            <a:schemeClr val="accent1"/>
+          </a:effectRef>
+          <a:fontRef idx="minor">
+            <a:schemeClr val="tx1"/>
+          </a:fontRef>
+        </p:style>
+      </p:cxnSp>
     </p:spTree>
     <p:extLst>
       <p:ext uri="{BB962C8B-B14F-4D97-AF65-F5344CB8AC3E}">

</xml_diff>

<commit_message>
reactivate green_experiments to compile and to run with a single subdomain, no parallelism
</commit_message>
<xml_diff>
--- a/doc/big_picture.pptx
+++ b/doc/big_picture.pptx
@@ -9,8 +9,8 @@
   </p:notesMasterIdLst>
   <p:sldIdLst>
     <p:sldId id="256" r:id="rId2"/>
-    <p:sldId id="257" r:id="rId3"/>
-    <p:sldId id="258" r:id="rId4"/>
+    <p:sldId id="260" r:id="rId3"/>
+    <p:sldId id="261" r:id="rId4"/>
   </p:sldIdLst>
   <p:sldSz cx="12801600" cy="9601200" type="A3"/>
   <p:notesSz cx="6858000" cy="9144000"/>
@@ -210,7 +210,7 @@
           <a:p>
             <a:fld id="{0FF26850-8575-9945-A6DF-A0798D281566}" type="datetimeFigureOut">
               <a:rPr lang="de-DE" smtClean="0"/>
-              <a:t>11.03.26</a:t>
+              <a:t>13.03.26</a:t>
             </a:fld>
             <a:endParaRPr lang="de-DE"/>
           </a:p>
@@ -567,7 +567,13 @@
   <p:cSld>
     <p:spTree>
       <p:nvGrpSpPr>
-        <p:cNvPr id="1" name=""/>
+        <p:cNvPr id="1" name="">
+          <a:extLst>
+            <a:ext uri="{FF2B5EF4-FFF2-40B4-BE49-F238E27FC236}">
+              <a16:creationId xmlns:a16="http://schemas.microsoft.com/office/drawing/2014/main" id="{AADF98F8-6178-8186-55E8-9E466D47658E}"/>
+            </a:ext>
+          </a:extLst>
+        </p:cNvPr>
         <p:cNvGrpSpPr/>
         <p:nvPr/>
       </p:nvGrpSpPr>
@@ -581,7 +587,13 @@
       </p:grpSpPr>
       <p:sp>
         <p:nvSpPr>
-          <p:cNvPr id="2" name="Slide Image Placeholder 1"/>
+          <p:cNvPr id="2" name="Slide Image Placeholder 1">
+            <a:extLst>
+              <a:ext uri="{FF2B5EF4-FFF2-40B4-BE49-F238E27FC236}">
+                <a16:creationId xmlns:a16="http://schemas.microsoft.com/office/drawing/2014/main" id="{F5096AC5-2FA2-E128-FFD2-CFE26319C944}"/>
+              </a:ext>
+            </a:extLst>
+          </p:cNvPr>
           <p:cNvSpPr>
             <a:spLocks noGrp="1" noRot="1" noChangeAspect="1"/>
           </p:cNvSpPr>
@@ -593,7 +605,13 @@
       </p:sp>
       <p:sp>
         <p:nvSpPr>
-          <p:cNvPr id="3" name="Notes Placeholder 2"/>
+          <p:cNvPr id="3" name="Notes Placeholder 2">
+            <a:extLst>
+              <a:ext uri="{FF2B5EF4-FFF2-40B4-BE49-F238E27FC236}">
+                <a16:creationId xmlns:a16="http://schemas.microsoft.com/office/drawing/2014/main" id="{C6A77FCC-9234-0EB5-7CFC-27617959F388}"/>
+              </a:ext>
+            </a:extLst>
+          </p:cNvPr>
           <p:cNvSpPr>
             <a:spLocks noGrp="1"/>
           </p:cNvSpPr>
@@ -612,7 +630,13 @@
       </p:sp>
       <p:sp>
         <p:nvSpPr>
-          <p:cNvPr id="4" name="Slide Number Placeholder 3"/>
+          <p:cNvPr id="4" name="Slide Number Placeholder 3">
+            <a:extLst>
+              <a:ext uri="{FF2B5EF4-FFF2-40B4-BE49-F238E27FC236}">
+                <a16:creationId xmlns:a16="http://schemas.microsoft.com/office/drawing/2014/main" id="{D5238CEC-BF9A-6E91-D9E7-9087650490BB}"/>
+              </a:ext>
+            </a:extLst>
+          </p:cNvPr>
           <p:cNvSpPr>
             <a:spLocks noGrp="1"/>
           </p:cNvSpPr>
@@ -636,7 +660,7 @@
     </p:spTree>
     <p:extLst>
       <p:ext uri="{BB962C8B-B14F-4D97-AF65-F5344CB8AC3E}">
-        <p14:creationId xmlns:p14="http://schemas.microsoft.com/office/powerpoint/2010/main" val="2776413999"/>
+        <p14:creationId xmlns:p14="http://schemas.microsoft.com/office/powerpoint/2010/main" val="611144328"/>
       </p:ext>
     </p:extLst>
   </p:cSld>
@@ -651,7 +675,13 @@
   <p:cSld>
     <p:spTree>
       <p:nvGrpSpPr>
-        <p:cNvPr id="1" name=""/>
+        <p:cNvPr id="1" name="">
+          <a:extLst>
+            <a:ext uri="{FF2B5EF4-FFF2-40B4-BE49-F238E27FC236}">
+              <a16:creationId xmlns:a16="http://schemas.microsoft.com/office/drawing/2014/main" id="{67CD3707-B6FF-7D3D-7943-B90EB8729139}"/>
+            </a:ext>
+          </a:extLst>
+        </p:cNvPr>
         <p:cNvGrpSpPr/>
         <p:nvPr/>
       </p:nvGrpSpPr>
@@ -665,7 +695,13 @@
       </p:grpSpPr>
       <p:sp>
         <p:nvSpPr>
-          <p:cNvPr id="2" name="Slide Image Placeholder 1"/>
+          <p:cNvPr id="2" name="Slide Image Placeholder 1">
+            <a:extLst>
+              <a:ext uri="{FF2B5EF4-FFF2-40B4-BE49-F238E27FC236}">
+                <a16:creationId xmlns:a16="http://schemas.microsoft.com/office/drawing/2014/main" id="{7E88EAB1-F46F-76A1-388F-B74B22A91C6C}"/>
+              </a:ext>
+            </a:extLst>
+          </p:cNvPr>
           <p:cNvSpPr>
             <a:spLocks noGrp="1" noRot="1" noChangeAspect="1"/>
           </p:cNvSpPr>
@@ -677,7 +713,13 @@
       </p:sp>
       <p:sp>
         <p:nvSpPr>
-          <p:cNvPr id="3" name="Notes Placeholder 2"/>
+          <p:cNvPr id="3" name="Notes Placeholder 2">
+            <a:extLst>
+              <a:ext uri="{FF2B5EF4-FFF2-40B4-BE49-F238E27FC236}">
+                <a16:creationId xmlns:a16="http://schemas.microsoft.com/office/drawing/2014/main" id="{3BB84617-4122-B892-D9C7-6BE50BBFB1E3}"/>
+              </a:ext>
+            </a:extLst>
+          </p:cNvPr>
           <p:cNvSpPr>
             <a:spLocks noGrp="1"/>
           </p:cNvSpPr>
@@ -696,7 +738,13 @@
       </p:sp>
       <p:sp>
         <p:nvSpPr>
-          <p:cNvPr id="4" name="Slide Number Placeholder 3"/>
+          <p:cNvPr id="4" name="Slide Number Placeholder 3">
+            <a:extLst>
+              <a:ext uri="{FF2B5EF4-FFF2-40B4-BE49-F238E27FC236}">
+                <a16:creationId xmlns:a16="http://schemas.microsoft.com/office/drawing/2014/main" id="{39F451E6-4470-ED45-DBEE-3B0E35EAB804}"/>
+              </a:ext>
+            </a:extLst>
+          </p:cNvPr>
           <p:cNvSpPr>
             <a:spLocks noGrp="1"/>
           </p:cNvSpPr>
@@ -720,7 +768,7 @@
     </p:spTree>
     <p:extLst>
       <p:ext uri="{BB962C8B-B14F-4D97-AF65-F5344CB8AC3E}">
-        <p14:creationId xmlns:p14="http://schemas.microsoft.com/office/powerpoint/2010/main" val="2249009279"/>
+        <p14:creationId xmlns:p14="http://schemas.microsoft.com/office/powerpoint/2010/main" val="3794656703"/>
       </p:ext>
     </p:extLst>
   </p:cSld>
@@ -861,7 +909,7 @@
           <a:p>
             <a:fld id="{60A3E910-B59F-F444-BE29-3A643468020D}" type="datetimeFigureOut">
               <a:rPr lang="de-DE" smtClean="0"/>
-              <a:t>11.03.26</a:t>
+              <a:t>13.03.26</a:t>
             </a:fld>
             <a:endParaRPr lang="de-DE"/>
           </a:p>
@@ -1031,7 +1079,7 @@
           <a:p>
             <a:fld id="{60A3E910-B59F-F444-BE29-3A643468020D}" type="datetimeFigureOut">
               <a:rPr lang="de-DE" smtClean="0"/>
-              <a:t>11.03.26</a:t>
+              <a:t>13.03.26</a:t>
             </a:fld>
             <a:endParaRPr lang="de-DE"/>
           </a:p>
@@ -1211,7 +1259,7 @@
           <a:p>
             <a:fld id="{60A3E910-B59F-F444-BE29-3A643468020D}" type="datetimeFigureOut">
               <a:rPr lang="de-DE" smtClean="0"/>
-              <a:t>11.03.26</a:t>
+              <a:t>13.03.26</a:t>
             </a:fld>
             <a:endParaRPr lang="de-DE"/>
           </a:p>
@@ -1381,7 +1429,7 @@
           <a:p>
             <a:fld id="{60A3E910-B59F-F444-BE29-3A643468020D}" type="datetimeFigureOut">
               <a:rPr lang="de-DE" smtClean="0"/>
-              <a:t>11.03.26</a:t>
+              <a:t>13.03.26</a:t>
             </a:fld>
             <a:endParaRPr lang="de-DE"/>
           </a:p>
@@ -1625,7 +1673,7 @@
           <a:p>
             <a:fld id="{60A3E910-B59F-F444-BE29-3A643468020D}" type="datetimeFigureOut">
               <a:rPr lang="de-DE" smtClean="0"/>
-              <a:t>11.03.26</a:t>
+              <a:t>13.03.26</a:t>
             </a:fld>
             <a:endParaRPr lang="de-DE"/>
           </a:p>
@@ -1857,7 +1905,7 @@
           <a:p>
             <a:fld id="{60A3E910-B59F-F444-BE29-3A643468020D}" type="datetimeFigureOut">
               <a:rPr lang="de-DE" smtClean="0"/>
-              <a:t>11.03.26</a:t>
+              <a:t>13.03.26</a:t>
             </a:fld>
             <a:endParaRPr lang="de-DE"/>
           </a:p>
@@ -2224,7 +2272,7 @@
           <a:p>
             <a:fld id="{60A3E910-B59F-F444-BE29-3A643468020D}" type="datetimeFigureOut">
               <a:rPr lang="de-DE" smtClean="0"/>
-              <a:t>11.03.26</a:t>
+              <a:t>13.03.26</a:t>
             </a:fld>
             <a:endParaRPr lang="de-DE"/>
           </a:p>
@@ -2342,7 +2390,7 @@
           <a:p>
             <a:fld id="{60A3E910-B59F-F444-BE29-3A643468020D}" type="datetimeFigureOut">
               <a:rPr lang="de-DE" smtClean="0"/>
-              <a:t>11.03.26</a:t>
+              <a:t>13.03.26</a:t>
             </a:fld>
             <a:endParaRPr lang="de-DE"/>
           </a:p>
@@ -2437,7 +2485,7 @@
           <a:p>
             <a:fld id="{60A3E910-B59F-F444-BE29-3A643468020D}" type="datetimeFigureOut">
               <a:rPr lang="de-DE" smtClean="0"/>
-              <a:t>11.03.26</a:t>
+              <a:t>13.03.26</a:t>
             </a:fld>
             <a:endParaRPr lang="de-DE"/>
           </a:p>
@@ -2714,7 +2762,7 @@
           <a:p>
             <a:fld id="{60A3E910-B59F-F444-BE29-3A643468020D}" type="datetimeFigureOut">
               <a:rPr lang="de-DE" smtClean="0"/>
-              <a:t>11.03.26</a:t>
+              <a:t>13.03.26</a:t>
             </a:fld>
             <a:endParaRPr lang="de-DE"/>
           </a:p>
@@ -2971,7 +3019,7 @@
           <a:p>
             <a:fld id="{60A3E910-B59F-F444-BE29-3A643468020D}" type="datetimeFigureOut">
               <a:rPr lang="de-DE" smtClean="0"/>
-              <a:t>11.03.26</a:t>
+              <a:t>13.03.26</a:t>
             </a:fld>
             <a:endParaRPr lang="de-DE"/>
           </a:p>
@@ -3184,7 +3232,7 @@
           <a:p>
             <a:fld id="{60A3E910-B59F-F444-BE29-3A643468020D}" type="datetimeFigureOut">
               <a:rPr lang="de-DE" smtClean="0"/>
-              <a:t>11.03.26</a:t>
+              <a:t>13.03.26</a:t>
             </a:fld>
             <a:endParaRPr lang="de-DE"/>
           </a:p>
@@ -3700,7 +3748,7 @@
         </p:blipFill>
         <p:spPr>
           <a:xfrm>
-            <a:off x="9972168" y="574311"/>
+            <a:off x="380116" y="1284350"/>
             <a:ext cx="812800" cy="812800"/>
           </a:xfrm>
           <a:prstGeom prst="rect">
@@ -3722,10 +3770,10 @@
         </p:nvGrpSpPr>
         <p:grpSpPr>
           <a:xfrm>
-            <a:off x="2996971" y="2023600"/>
-            <a:ext cx="1726250" cy="812800"/>
+            <a:off x="1655211" y="2102968"/>
+            <a:ext cx="1969907" cy="812800"/>
             <a:chOff x="780378" y="5424549"/>
-            <a:chExt cx="1726250" cy="812800"/>
+            <a:chExt cx="1969907" cy="812800"/>
           </a:xfrm>
         </p:grpSpPr>
         <p:pic>
@@ -3774,8 +3822,8 @@
           </p:nvSpPr>
           <p:spPr>
             <a:xfrm>
-              <a:off x="1562139" y="5589956"/>
-              <a:ext cx="944489" cy="461665"/>
+              <a:off x="1562139" y="5528993"/>
+              <a:ext cx="1188146" cy="461665"/>
             </a:xfrm>
             <a:prstGeom prst="rect">
               <a:avLst/>
@@ -3830,11 +3878,18 @@
                 </a:rPr>
               </a:br>
               <a:r>
+                <a:rPr lang="de-DE" sz="1200" dirty="0" err="1">
+                  <a:latin typeface="Arial" panose="020B0604020202020204" pitchFamily="34" charset="0"/>
+                  <a:cs typeface="Arial" panose="020B0604020202020204" pitchFamily="34" charset="0"/>
+                </a:rPr>
+                <a:t>directory</a:t>
+              </a:r>
+              <a:r>
                 <a:rPr lang="de-DE" sz="1200" dirty="0">
                   <a:latin typeface="Arial" panose="020B0604020202020204" pitchFamily="34" charset="0"/>
                   <a:cs typeface="Arial" panose="020B0604020202020204" pitchFamily="34" charset="0"/>
                 </a:rPr>
-                <a:t>dir </a:t>
+                <a:t> </a:t>
               </a:r>
               <a:r>
                 <a:rPr lang="de-DE" sz="1200" dirty="0" err="1">
@@ -4259,7 +4314,7 @@
         </p:nvSpPr>
         <p:spPr>
           <a:xfrm>
-            <a:off x="9000000" y="2880000"/>
+            <a:off x="10800000" y="2160000"/>
             <a:ext cx="1260000" cy="540000"/>
           </a:xfrm>
           <a:prstGeom prst="roundRect">
@@ -4768,10 +4823,10 @@
         </p:nvGrpSpPr>
         <p:grpSpPr>
           <a:xfrm>
-            <a:off x="7200000" y="720000"/>
-            <a:ext cx="2767964" cy="540000"/>
-            <a:chOff x="6588961" y="855052"/>
-            <a:chExt cx="2767964" cy="540000"/>
+            <a:off x="1219876" y="1418278"/>
+            <a:ext cx="3640123" cy="547129"/>
+            <a:chOff x="4208838" y="847923"/>
+            <a:chExt cx="3640123" cy="547129"/>
           </a:xfrm>
         </p:grpSpPr>
         <p:sp>
@@ -4849,7 +4904,7 @@
           </p:nvSpPr>
           <p:spPr>
             <a:xfrm>
-              <a:off x="7966801" y="886855"/>
+              <a:off x="4208838" y="847923"/>
               <a:ext cx="1390124" cy="276999"/>
             </a:xfrm>
             <a:prstGeom prst="rect">
@@ -5049,7 +5104,7 @@
         </p:nvSpPr>
         <p:spPr>
           <a:xfrm>
-            <a:off x="9000000" y="3600000"/>
+            <a:off x="10800000" y="3600000"/>
             <a:ext cx="1260000" cy="540000"/>
           </a:xfrm>
           <a:prstGeom prst="roundRect">
@@ -5208,9 +5263,9 @@
           <p:nvPr/>
         </p:nvCxnSpPr>
         <p:spPr>
-          <a:xfrm rot="10800000">
-            <a:off x="4723222" y="2419840"/>
-            <a:ext cx="676779" cy="10160"/>
+          <a:xfrm rot="10800000" flipV="1">
+            <a:off x="3625118" y="2429999"/>
+            <a:ext cx="1774882" cy="8245"/>
           </a:xfrm>
           <a:prstGeom prst="bentConnector3">
             <a:avLst>
@@ -5249,15 +5304,15 @@
           </p:cNvPr>
           <p:cNvCxnSpPr>
             <a:cxnSpLocks/>
-            <a:stCxn id="14" idx="1"/>
-            <a:endCxn id="25" idx="3"/>
+            <a:stCxn id="14" idx="3"/>
+            <a:endCxn id="25" idx="1"/>
           </p:cNvCxnSpPr>
           <p:nvPr/>
         </p:nvCxnSpPr>
         <p:spPr>
-          <a:xfrm rot="10800000" flipV="1">
-            <a:off x="8460000" y="980710"/>
-            <a:ext cx="1512168" cy="9289"/>
+          <a:xfrm>
+            <a:off x="1192916" y="1690750"/>
+            <a:ext cx="2407083" cy="4657"/>
           </a:xfrm>
           <a:prstGeom prst="bentConnector3">
             <a:avLst>
@@ -6120,8 +6175,8 @@
         </p:nvSpPr>
         <p:spPr>
           <a:xfrm>
-            <a:off x="7200000" y="5760000"/>
-            <a:ext cx="1260000" cy="540000"/>
+            <a:off x="10800000" y="4320549"/>
+            <a:ext cx="1260000" cy="490448"/>
           </a:xfrm>
           <a:prstGeom prst="roundRect">
             <a:avLst/>
@@ -6210,7 +6265,7 @@
         </p:nvSpPr>
         <p:spPr>
           <a:xfrm>
-            <a:off x="1800000" y="720000"/>
+            <a:off x="7200000" y="708480"/>
             <a:ext cx="1260000" cy="540000"/>
           </a:xfrm>
           <a:prstGeom prst="roundRect">
@@ -6959,7 +7014,7 @@
         <p:spPr>
           <a:xfrm>
             <a:off x="11402876" y="6910655"/>
-            <a:ext cx="798617" cy="646331"/>
+            <a:ext cx="1079142" cy="276999"/>
           </a:xfrm>
           <a:prstGeom prst="rect">
             <a:avLst/>
@@ -6977,7 +7032,7 @@
                 <a:latin typeface="Arial" panose="020B0604020202020204" pitchFamily="34" charset="0"/>
                 <a:cs typeface="Arial" panose="020B0604020202020204" pitchFamily="34" charset="0"/>
               </a:rPr>
-              <a:t>data</a:t>
+              <a:t>flow</a:t>
             </a:r>
             <a:r>
               <a:rPr lang="de-DE" sz="1200" dirty="0">
@@ -6991,26 +7046,7 @@
                 <a:latin typeface="Arial" panose="020B0604020202020204" pitchFamily="34" charset="0"/>
                 <a:cs typeface="Arial" panose="020B0604020202020204" pitchFamily="34" charset="0"/>
               </a:rPr>
-              <a:t>flow</a:t>
-            </a:r>
-            <a:br>
-              <a:rPr lang="de-DE" sz="1200" dirty="0">
-                <a:latin typeface="Arial" panose="020B0604020202020204" pitchFamily="34" charset="0"/>
-                <a:cs typeface="Arial" panose="020B0604020202020204" pitchFamily="34" charset="0"/>
-              </a:rPr>
-            </a:br>
-            <a:br>
-              <a:rPr lang="de-DE" sz="1200" dirty="0">
-                <a:latin typeface="Arial" panose="020B0604020202020204" pitchFamily="34" charset="0"/>
-                <a:cs typeface="Arial" panose="020B0604020202020204" pitchFamily="34" charset="0"/>
-              </a:rPr>
-            </a:br>
-            <a:r>
-              <a:rPr lang="de-DE" sz="1200" dirty="0" err="1">
-                <a:latin typeface="Arial" panose="020B0604020202020204" pitchFamily="34" charset="0"/>
-                <a:cs typeface="Arial" panose="020B0604020202020204" pitchFamily="34" charset="0"/>
-              </a:rPr>
-              <a:t>includes</a:t>
+              <a:t>direction</a:t>
             </a:r>
             <a:endParaRPr lang="de-DE" sz="1200" dirty="0">
               <a:latin typeface="Courier" pitchFamily="2" charset="0"/>
@@ -7019,50 +7055,6 @@
           </a:p>
         </p:txBody>
       </p:sp>
-      <p:cxnSp>
-        <p:nvCxnSpPr>
-          <p:cNvPr id="322" name="Elbow Connector 321">
-            <a:extLst>
-              <a:ext uri="{FF2B5EF4-FFF2-40B4-BE49-F238E27FC236}">
-                <a16:creationId xmlns:a16="http://schemas.microsoft.com/office/drawing/2014/main" id="{A934EA42-B256-FC4E-8968-D71FDB11AA16}"/>
-              </a:ext>
-            </a:extLst>
-          </p:cNvPr>
-          <p:cNvCxnSpPr>
-            <a:cxnSpLocks/>
-          </p:cNvCxnSpPr>
-          <p:nvPr/>
-        </p:nvCxnSpPr>
-        <p:spPr>
-          <a:xfrm>
-            <a:off x="10945940" y="7437458"/>
-            <a:ext cx="407276" cy="3022"/>
-          </a:xfrm>
-          <a:prstGeom prst="bentConnector3">
-            <a:avLst>
-              <a:gd name="adj1" fmla="val 50000"/>
-            </a:avLst>
-          </a:prstGeom>
-          <a:ln>
-            <a:prstDash val="dash"/>
-            <a:tailEnd type="triangle"/>
-          </a:ln>
-        </p:spPr>
-        <p:style>
-          <a:lnRef idx="1">
-            <a:schemeClr val="accent1"/>
-          </a:lnRef>
-          <a:fillRef idx="0">
-            <a:schemeClr val="accent1"/>
-          </a:fillRef>
-          <a:effectRef idx="0">
-            <a:schemeClr val="accent1"/>
-          </a:effectRef>
-          <a:fontRef idx="minor">
-            <a:schemeClr val="tx1"/>
-          </a:fontRef>
-        </p:style>
-      </p:cxnSp>
       <p:sp>
         <p:nvSpPr>
           <p:cNvPr id="3" name="TextBox 2">
@@ -7077,8 +7069,8 @@
         </p:nvSpPr>
         <p:spPr>
           <a:xfrm>
-            <a:off x="380116" y="260967"/>
-            <a:ext cx="4789076" cy="461665"/>
+            <a:off x="380115" y="260967"/>
+            <a:ext cx="9204715" cy="461665"/>
           </a:xfrm>
           <a:prstGeom prst="rect">
             <a:avLst/>
@@ -7096,7 +7088,7 @@
                 <a:latin typeface="Courier New" panose="02070309020205020404" pitchFamily="49" charset="0"/>
                 <a:cs typeface="Courier New" panose="02070309020205020404" pitchFamily="49" charset="0"/>
               </a:rPr>
-              <a:t>AngstromCube/libliveatom</a:t>
+              <a:t>AngstromCube/libliveatom	DataFlow</a:t>
             </a:r>
           </a:p>
         </p:txBody>
@@ -7570,7 +7562,7 @@
             <a:pPr algn="ctr"/>
             <a:r>
               <a:rPr lang="en-DE" dirty="0"/>
-              <a:t>C-Interface</a:t>
+              <a:t>C  interface</a:t>
             </a:r>
             <a:br>
               <a:rPr lang="en-DE" dirty="0"/>
@@ -7671,51 +7663,7 @@
             </a:avLst>
           </a:prstGeom>
           <a:ln>
-            <a:prstDash val="dash"/>
-            <a:tailEnd type="triangle"/>
-          </a:ln>
-        </p:spPr>
-        <p:style>
-          <a:lnRef idx="1">
-            <a:schemeClr val="accent1"/>
-          </a:lnRef>
-          <a:fillRef idx="0">
-            <a:schemeClr val="accent1"/>
-          </a:fillRef>
-          <a:effectRef idx="0">
-            <a:schemeClr val="accent1"/>
-          </a:effectRef>
-          <a:fontRef idx="minor">
-            <a:schemeClr val="tx1"/>
-          </a:fontRef>
-        </p:style>
-      </p:cxnSp>
-      <p:cxnSp>
-        <p:nvCxnSpPr>
-          <p:cNvPr id="506" name="Elbow Connector 505">
-            <a:extLst>
-              <a:ext uri="{FF2B5EF4-FFF2-40B4-BE49-F238E27FC236}">
-                <a16:creationId xmlns:a16="http://schemas.microsoft.com/office/drawing/2014/main" id="{47D71CD8-95DB-2ABC-C0D2-44A75582A8E2}"/>
-              </a:ext>
-            </a:extLst>
-          </p:cNvPr>
-          <p:cNvCxnSpPr>
-            <a:cxnSpLocks/>
-            <a:stCxn id="144" idx="1"/>
-            <a:endCxn id="495" idx="0"/>
-          </p:cNvCxnSpPr>
-          <p:nvPr/>
-        </p:nvCxnSpPr>
-        <p:spPr>
-          <a:xfrm rot="10800000" flipV="1">
-            <a:off x="6030000" y="6030000"/>
-            <a:ext cx="1170001" cy="687458"/>
-          </a:xfrm>
-          <a:prstGeom prst="bentConnector2">
-            <a:avLst/>
-          </a:prstGeom>
-          <a:ln>
-            <a:prstDash val="dash"/>
+            <a:prstDash val="solid"/>
             <a:tailEnd type="triangle"/>
           </a:ln>
         </p:spPr>
@@ -7854,6 +7802,187 @@
           </a:p>
         </p:txBody>
       </p:sp>
+      <p:cxnSp>
+        <p:nvCxnSpPr>
+          <p:cNvPr id="8" name="Elbow Connector 7">
+            <a:extLst>
+              <a:ext uri="{FF2B5EF4-FFF2-40B4-BE49-F238E27FC236}">
+                <a16:creationId xmlns:a16="http://schemas.microsoft.com/office/drawing/2014/main" id="{90F71C3F-25B7-3BC9-AE17-DDD07BD4BA57}"/>
+              </a:ext>
+            </a:extLst>
+          </p:cNvPr>
+          <p:cNvCxnSpPr>
+            <a:cxnSpLocks/>
+            <a:stCxn id="36" idx="0"/>
+            <a:endCxn id="40" idx="2"/>
+          </p:cNvCxnSpPr>
+          <p:nvPr/>
+        </p:nvCxnSpPr>
+        <p:spPr>
+          <a:xfrm rot="5400000" flipH="1" flipV="1">
+            <a:off x="7740000" y="3510000"/>
+            <a:ext cx="180000" cy="12700"/>
+          </a:xfrm>
+          <a:prstGeom prst="bentConnector3">
+            <a:avLst>
+              <a:gd name="adj1" fmla="val 50000"/>
+            </a:avLst>
+          </a:prstGeom>
+          <a:ln>
+            <a:prstDash val="solid"/>
+            <a:headEnd type="triangle"/>
+            <a:tailEnd type="triangle"/>
+          </a:ln>
+        </p:spPr>
+        <p:style>
+          <a:lnRef idx="1">
+            <a:schemeClr val="accent1"/>
+          </a:lnRef>
+          <a:fillRef idx="0">
+            <a:schemeClr val="accent1"/>
+          </a:fillRef>
+          <a:effectRef idx="0">
+            <a:schemeClr val="accent1"/>
+          </a:effectRef>
+          <a:fontRef idx="minor">
+            <a:schemeClr val="tx1"/>
+          </a:fontRef>
+        </p:style>
+      </p:cxnSp>
+      <p:cxnSp>
+        <p:nvCxnSpPr>
+          <p:cNvPr id="11" name="Elbow Connector 10">
+            <a:extLst>
+              <a:ext uri="{FF2B5EF4-FFF2-40B4-BE49-F238E27FC236}">
+                <a16:creationId xmlns:a16="http://schemas.microsoft.com/office/drawing/2014/main" id="{C3A38009-750B-7C44-03A6-1E81136D49CB}"/>
+              </a:ext>
+            </a:extLst>
+          </p:cNvPr>
+          <p:cNvCxnSpPr>
+            <a:cxnSpLocks/>
+            <a:stCxn id="40" idx="3"/>
+            <a:endCxn id="41" idx="2"/>
+          </p:cNvCxnSpPr>
+          <p:nvPr/>
+        </p:nvCxnSpPr>
+        <p:spPr>
+          <a:xfrm flipV="1">
+            <a:off x="8460000" y="2700000"/>
+            <a:ext cx="1170000" cy="450000"/>
+          </a:xfrm>
+          <a:prstGeom prst="bentConnector2">
+            <a:avLst/>
+          </a:prstGeom>
+          <a:ln>
+            <a:tailEnd type="triangle"/>
+          </a:ln>
+        </p:spPr>
+        <p:style>
+          <a:lnRef idx="1">
+            <a:schemeClr val="accent1"/>
+          </a:lnRef>
+          <a:fillRef idx="0">
+            <a:schemeClr val="accent1"/>
+          </a:fillRef>
+          <a:effectRef idx="0">
+            <a:schemeClr val="accent1"/>
+          </a:effectRef>
+          <a:fontRef idx="minor">
+            <a:schemeClr val="tx1"/>
+          </a:fontRef>
+        </p:style>
+      </p:cxnSp>
+      <p:cxnSp>
+        <p:nvCxnSpPr>
+          <p:cNvPr id="15" name="Elbow Connector 14">
+            <a:extLst>
+              <a:ext uri="{FF2B5EF4-FFF2-40B4-BE49-F238E27FC236}">
+                <a16:creationId xmlns:a16="http://schemas.microsoft.com/office/drawing/2014/main" id="{9AB9E9B0-D0E8-75DC-9AD6-7689DA6F0982}"/>
+              </a:ext>
+            </a:extLst>
+          </p:cNvPr>
+          <p:cNvCxnSpPr>
+            <a:cxnSpLocks/>
+            <a:stCxn id="26" idx="2"/>
+            <a:endCxn id="28" idx="0"/>
+          </p:cNvCxnSpPr>
+          <p:nvPr/>
+        </p:nvCxnSpPr>
+        <p:spPr>
+          <a:xfrm rot="16200000" flipH="1">
+            <a:off x="4139999" y="4949999"/>
+            <a:ext cx="180000" cy="1"/>
+          </a:xfrm>
+          <a:prstGeom prst="bentConnector3">
+            <a:avLst>
+              <a:gd name="adj1" fmla="val 50000"/>
+            </a:avLst>
+          </a:prstGeom>
+          <a:ln>
+            <a:tailEnd type="triangle"/>
+          </a:ln>
+        </p:spPr>
+        <p:style>
+          <a:lnRef idx="1">
+            <a:schemeClr val="accent1"/>
+          </a:lnRef>
+          <a:fillRef idx="0">
+            <a:schemeClr val="accent1"/>
+          </a:fillRef>
+          <a:effectRef idx="0">
+            <a:schemeClr val="accent1"/>
+          </a:effectRef>
+          <a:fontRef idx="minor">
+            <a:schemeClr val="tx1"/>
+          </a:fontRef>
+        </p:style>
+      </p:cxnSp>
+      <p:cxnSp>
+        <p:nvCxnSpPr>
+          <p:cNvPr id="24" name="Elbow Connector 23">
+            <a:extLst>
+              <a:ext uri="{FF2B5EF4-FFF2-40B4-BE49-F238E27FC236}">
+                <a16:creationId xmlns:a16="http://schemas.microsoft.com/office/drawing/2014/main" id="{9F078242-4C27-559D-9A15-52F2291A3FB7}"/>
+              </a:ext>
+            </a:extLst>
+          </p:cNvPr>
+          <p:cNvCxnSpPr>
+            <a:cxnSpLocks/>
+            <a:stCxn id="47" idx="3"/>
+            <a:endCxn id="28" idx="1"/>
+          </p:cNvCxnSpPr>
+          <p:nvPr/>
+        </p:nvCxnSpPr>
+        <p:spPr>
+          <a:xfrm>
+            <a:off x="3060000" y="5310000"/>
+            <a:ext cx="540000" cy="12700"/>
+          </a:xfrm>
+          <a:prstGeom prst="bentConnector3">
+            <a:avLst>
+              <a:gd name="adj1" fmla="val 50000"/>
+            </a:avLst>
+          </a:prstGeom>
+          <a:ln>
+            <a:prstDash val="solid"/>
+            <a:tailEnd type="triangle"/>
+          </a:ln>
+        </p:spPr>
+        <p:style>
+          <a:lnRef idx="1">
+            <a:schemeClr val="accent1"/>
+          </a:lnRef>
+          <a:fillRef idx="0">
+            <a:schemeClr val="accent1"/>
+          </a:fillRef>
+          <a:effectRef idx="0">
+            <a:schemeClr val="accent1"/>
+          </a:effectRef>
+          <a:fontRef idx="minor">
+            <a:schemeClr val="tx1"/>
+          </a:fontRef>
+        </p:style>
+      </p:cxnSp>
     </p:spTree>
     <p:extLst>
       <p:ext uri="{BB962C8B-B14F-4D97-AF65-F5344CB8AC3E}">
@@ -7872,7 +8001,13 @@
   <p:cSld>
     <p:spTree>
       <p:nvGrpSpPr>
-        <p:cNvPr id="1" name=""/>
+        <p:cNvPr id="1" name="">
+          <a:extLst>
+            <a:ext uri="{FF2B5EF4-FFF2-40B4-BE49-F238E27FC236}">
+              <a16:creationId xmlns:a16="http://schemas.microsoft.com/office/drawing/2014/main" id="{8C632995-3545-7C37-9BBE-FEBE91F37805}"/>
+            </a:ext>
+          </a:extLst>
+        </p:cNvPr>
         <p:cNvGrpSpPr/>
         <p:nvPr/>
       </p:nvGrpSpPr>
@@ -7889,7 +8024,7 @@
           <p:cNvPr id="381" name="Rectangle 380">
             <a:extLst>
               <a:ext uri="{FF2B5EF4-FFF2-40B4-BE49-F238E27FC236}">
-                <a16:creationId xmlns:a16="http://schemas.microsoft.com/office/drawing/2014/main" id="{5A95D46E-86C0-7C41-9B33-C47148B06BC4}"/>
+                <a16:creationId xmlns:a16="http://schemas.microsoft.com/office/drawing/2014/main" id="{1B0E0B42-9C5D-4B08-C510-5097682003E0}"/>
               </a:ext>
             </a:extLst>
           </p:cNvPr>
@@ -7978,7 +8113,7 @@
           <p:cNvPr id="5" name="Picture 4">
             <a:extLst>
               <a:ext uri="{FF2B5EF4-FFF2-40B4-BE49-F238E27FC236}">
-                <a16:creationId xmlns:a16="http://schemas.microsoft.com/office/drawing/2014/main" id="{55738121-16F2-BA4C-9405-759F95BDB794}"/>
+                <a16:creationId xmlns:a16="http://schemas.microsoft.com/office/drawing/2014/main" id="{5498CD6D-D362-6D0F-EFDA-2A6861CDD0EC}"/>
               </a:ext>
             </a:extLst>
           </p:cNvPr>
@@ -8008,7 +8143,7 @@
           <p:cNvPr id="11" name="Rounded Rectangle 10">
             <a:extLst>
               <a:ext uri="{FF2B5EF4-FFF2-40B4-BE49-F238E27FC236}">
-                <a16:creationId xmlns:a16="http://schemas.microsoft.com/office/drawing/2014/main" id="{E0F7237A-5BD2-CE4B-AFE3-2FA12196F42B}"/>
+                <a16:creationId xmlns:a16="http://schemas.microsoft.com/office/drawing/2014/main" id="{3ED8D8AD-94F1-D0B6-F2B0-AE218B15D5A3}"/>
               </a:ext>
             </a:extLst>
           </p:cNvPr>
@@ -8086,7 +8221,7 @@
           <p:cNvPr id="12" name="Rounded Rectangle 11">
             <a:extLst>
               <a:ext uri="{FF2B5EF4-FFF2-40B4-BE49-F238E27FC236}">
-                <a16:creationId xmlns:a16="http://schemas.microsoft.com/office/drawing/2014/main" id="{CE154B7B-82F0-7549-9D5F-E41EA47F2C81}"/>
+                <a16:creationId xmlns:a16="http://schemas.microsoft.com/office/drawing/2014/main" id="{D6B79C79-CF3C-C5FC-760D-92AA69699172}"/>
               </a:ext>
             </a:extLst>
           </p:cNvPr>
@@ -8164,7 +8299,7 @@
           <p:cNvPr id="18" name="Group 17">
             <a:extLst>
               <a:ext uri="{FF2B5EF4-FFF2-40B4-BE49-F238E27FC236}">
-                <a16:creationId xmlns:a16="http://schemas.microsoft.com/office/drawing/2014/main" id="{CA89CFFD-1DBB-6543-81EC-4C388E067F44}"/>
+                <a16:creationId xmlns:a16="http://schemas.microsoft.com/office/drawing/2014/main" id="{C02DC75D-DCB5-AC28-CB8E-52FB093ED3E6}"/>
               </a:ext>
             </a:extLst>
           </p:cNvPr>
@@ -8184,7 +8319,7 @@
             <p:cNvPr id="14" name="Picture 13">
               <a:extLst>
                 <a:ext uri="{FF2B5EF4-FFF2-40B4-BE49-F238E27FC236}">
-                  <a16:creationId xmlns:a16="http://schemas.microsoft.com/office/drawing/2014/main" id="{09E502DF-15DF-CA4C-BCFE-F7ECBE069BA9}"/>
+                  <a16:creationId xmlns:a16="http://schemas.microsoft.com/office/drawing/2014/main" id="{0FD1F6EA-BCCB-B1B7-BE3F-C1526E670D8C}"/>
                 </a:ext>
               </a:extLst>
             </p:cNvPr>
@@ -8216,7 +8351,7 @@
             <p:cNvPr id="17" name="TextBox 16">
               <a:extLst>
                 <a:ext uri="{FF2B5EF4-FFF2-40B4-BE49-F238E27FC236}">
-                  <a16:creationId xmlns:a16="http://schemas.microsoft.com/office/drawing/2014/main" id="{CF02BABB-4440-3345-8ECD-39B0A099AC1B}"/>
+                  <a16:creationId xmlns:a16="http://schemas.microsoft.com/office/drawing/2014/main" id="{18D9F709-AE85-DCA1-FD7C-A2DE33CABEEB}"/>
                 </a:ext>
               </a:extLst>
             </p:cNvPr>
@@ -8264,7 +8399,7 @@
           <p:cNvPr id="21" name="Rounded Rectangle 20">
             <a:extLst>
               <a:ext uri="{FF2B5EF4-FFF2-40B4-BE49-F238E27FC236}">
-                <a16:creationId xmlns:a16="http://schemas.microsoft.com/office/drawing/2014/main" id="{F395E9D4-AE4F-FE4E-8B3F-F7DD030707C3}"/>
+                <a16:creationId xmlns:a16="http://schemas.microsoft.com/office/drawing/2014/main" id="{84FA8344-2B92-CBF1-C2A4-C91EBDBAB8AF}"/>
               </a:ext>
             </a:extLst>
           </p:cNvPr>
@@ -8342,7 +8477,7 @@
           <p:cNvPr id="22" name="Rounded Rectangle 21">
             <a:extLst>
               <a:ext uri="{FF2B5EF4-FFF2-40B4-BE49-F238E27FC236}">
-                <a16:creationId xmlns:a16="http://schemas.microsoft.com/office/drawing/2014/main" id="{C46A3FE9-B3DC-1A40-8877-FEC5EEDAA212}"/>
+                <a16:creationId xmlns:a16="http://schemas.microsoft.com/office/drawing/2014/main" id="{A3C70DAA-9EEC-9413-D349-003CB57A8E05}"/>
               </a:ext>
             </a:extLst>
           </p:cNvPr>
@@ -8420,7 +8555,7 @@
           <p:cNvPr id="26" name="Rounded Rectangle 25">
             <a:extLst>
               <a:ext uri="{FF2B5EF4-FFF2-40B4-BE49-F238E27FC236}">
-                <a16:creationId xmlns:a16="http://schemas.microsoft.com/office/drawing/2014/main" id="{6CD602C6-456F-C144-8760-5A3B06685886}"/>
+                <a16:creationId xmlns:a16="http://schemas.microsoft.com/office/drawing/2014/main" id="{35E8C79F-CA10-40C9-629A-77655B54EB57}"/>
               </a:ext>
             </a:extLst>
           </p:cNvPr>
@@ -8498,7 +8633,7 @@
           <p:cNvPr id="27" name="Rounded Rectangle 26">
             <a:extLst>
               <a:ext uri="{FF2B5EF4-FFF2-40B4-BE49-F238E27FC236}">
-                <a16:creationId xmlns:a16="http://schemas.microsoft.com/office/drawing/2014/main" id="{1D6E5ED0-21DE-9245-8DF0-0703B5C57762}"/>
+                <a16:creationId xmlns:a16="http://schemas.microsoft.com/office/drawing/2014/main" id="{4605502C-3DD1-F8F7-ECAA-A45ECEB5E366}"/>
               </a:ext>
             </a:extLst>
           </p:cNvPr>
@@ -8576,7 +8711,7 @@
           <p:cNvPr id="29" name="Rounded Rectangle 28">
             <a:extLst>
               <a:ext uri="{FF2B5EF4-FFF2-40B4-BE49-F238E27FC236}">
-                <a16:creationId xmlns:a16="http://schemas.microsoft.com/office/drawing/2014/main" id="{8290A799-096F-A349-8AD8-282279FE8A68}"/>
+                <a16:creationId xmlns:a16="http://schemas.microsoft.com/office/drawing/2014/main" id="{417A28A7-9B5F-FE98-2C2C-6692F913BDDA}"/>
               </a:ext>
             </a:extLst>
           </p:cNvPr>
@@ -8655,7 +8790,7 @@
           <p:cNvPr id="31" name="Rounded Rectangle 30">
             <a:extLst>
               <a:ext uri="{FF2B5EF4-FFF2-40B4-BE49-F238E27FC236}">
-                <a16:creationId xmlns:a16="http://schemas.microsoft.com/office/drawing/2014/main" id="{4C150C1E-F2E2-D34A-8F82-337E73C3DB73}"/>
+                <a16:creationId xmlns:a16="http://schemas.microsoft.com/office/drawing/2014/main" id="{DD459174-F3A1-F2BB-149C-F305442FC98E}"/>
               </a:ext>
             </a:extLst>
           </p:cNvPr>
@@ -8733,7 +8868,7 @@
           <p:cNvPr id="36" name="Rounded Rectangle 35">
             <a:extLst>
               <a:ext uri="{FF2B5EF4-FFF2-40B4-BE49-F238E27FC236}">
-                <a16:creationId xmlns:a16="http://schemas.microsoft.com/office/drawing/2014/main" id="{BFDA6D5C-B7DA-C241-B76D-C398410DD83F}"/>
+                <a16:creationId xmlns:a16="http://schemas.microsoft.com/office/drawing/2014/main" id="{EE74B044-7F49-A572-2980-77B62C68B71A}"/>
               </a:ext>
             </a:extLst>
           </p:cNvPr>
@@ -8812,7 +8947,7 @@
           <p:cNvPr id="37" name="Rounded Rectangle 36">
             <a:extLst>
               <a:ext uri="{FF2B5EF4-FFF2-40B4-BE49-F238E27FC236}">
-                <a16:creationId xmlns:a16="http://schemas.microsoft.com/office/drawing/2014/main" id="{0882E9FB-3DCD-5645-B675-E05F0BAA87E7}"/>
+                <a16:creationId xmlns:a16="http://schemas.microsoft.com/office/drawing/2014/main" id="{41673577-F24A-6B42-D322-207C8F811D0A}"/>
               </a:ext>
             </a:extLst>
           </p:cNvPr>
@@ -8891,7 +9026,7 @@
           <p:cNvPr id="38" name="Rounded Rectangle 37">
             <a:extLst>
               <a:ext uri="{FF2B5EF4-FFF2-40B4-BE49-F238E27FC236}">
-                <a16:creationId xmlns:a16="http://schemas.microsoft.com/office/drawing/2014/main" id="{5D1DD86E-041E-B946-8D0B-C1A43AA104E3}"/>
+                <a16:creationId xmlns:a16="http://schemas.microsoft.com/office/drawing/2014/main" id="{3D3CDC54-6A77-F01D-366F-5D3DD1B00EE5}"/>
               </a:ext>
             </a:extLst>
           </p:cNvPr>
@@ -8970,7 +9105,7 @@
           <p:cNvPr id="39" name="Rounded Rectangle 38">
             <a:extLst>
               <a:ext uri="{FF2B5EF4-FFF2-40B4-BE49-F238E27FC236}">
-                <a16:creationId xmlns:a16="http://schemas.microsoft.com/office/drawing/2014/main" id="{A735A9AE-E1F9-7C44-ACDD-90715307FAC0}"/>
+                <a16:creationId xmlns:a16="http://schemas.microsoft.com/office/drawing/2014/main" id="{FC8C83FB-529E-3FCB-51E9-446FD5E875EF}"/>
               </a:ext>
             </a:extLst>
           </p:cNvPr>
@@ -9049,7 +9184,7 @@
           <p:cNvPr id="43" name="Group 42">
             <a:extLst>
               <a:ext uri="{FF2B5EF4-FFF2-40B4-BE49-F238E27FC236}">
-                <a16:creationId xmlns:a16="http://schemas.microsoft.com/office/drawing/2014/main" id="{10853068-37EB-4744-A336-79E97BB0D2AC}"/>
+                <a16:creationId xmlns:a16="http://schemas.microsoft.com/office/drawing/2014/main" id="{3FF40AAB-CFC1-DCC5-00E5-BE9A13BF2EF6}"/>
               </a:ext>
             </a:extLst>
           </p:cNvPr>
@@ -9069,7 +9204,7 @@
             <p:cNvPr id="25" name="Rounded Rectangle 24">
               <a:extLst>
                 <a:ext uri="{FF2B5EF4-FFF2-40B4-BE49-F238E27FC236}">
-                  <a16:creationId xmlns:a16="http://schemas.microsoft.com/office/drawing/2014/main" id="{C3E087B7-06E3-594C-8B7A-ECF3019A1144}"/>
+                  <a16:creationId xmlns:a16="http://schemas.microsoft.com/office/drawing/2014/main" id="{7E96B2AD-C4D8-CE30-8636-305B65C1D124}"/>
                 </a:ext>
               </a:extLst>
             </p:cNvPr>
@@ -9130,7 +9265,7 @@
             <p:cNvPr id="42" name="TextBox 41">
               <a:extLst>
                 <a:ext uri="{FF2B5EF4-FFF2-40B4-BE49-F238E27FC236}">
-                  <a16:creationId xmlns:a16="http://schemas.microsoft.com/office/drawing/2014/main" id="{263DDD99-7AC2-0346-8B24-EE4346954CE0}"/>
+                  <a16:creationId xmlns:a16="http://schemas.microsoft.com/office/drawing/2014/main" id="{76DEC4FA-C428-6DC4-973B-A19FC38AF65A}"/>
                 </a:ext>
               </a:extLst>
             </p:cNvPr>
@@ -9201,7 +9336,7 @@
           <p:cNvPr id="49" name="Rounded Rectangle 48">
             <a:extLst>
               <a:ext uri="{FF2B5EF4-FFF2-40B4-BE49-F238E27FC236}">
-                <a16:creationId xmlns:a16="http://schemas.microsoft.com/office/drawing/2014/main" id="{60628BA6-162F-984D-9EAD-17C23EB4A33A}"/>
+                <a16:creationId xmlns:a16="http://schemas.microsoft.com/office/drawing/2014/main" id="{83822741-7A80-3F78-A6A1-07BDA59C5D4A}"/>
               </a:ext>
             </a:extLst>
           </p:cNvPr>
@@ -9280,7 +9415,7 @@
           <p:cNvPr id="44" name="Rounded Rectangle 43">
             <a:extLst>
               <a:ext uri="{FF2B5EF4-FFF2-40B4-BE49-F238E27FC236}">
-                <a16:creationId xmlns:a16="http://schemas.microsoft.com/office/drawing/2014/main" id="{5F26C983-CECD-9D4C-BB43-61181C7B1C14}"/>
+                <a16:creationId xmlns:a16="http://schemas.microsoft.com/office/drawing/2014/main" id="{16B22DD2-C834-355E-6B48-0416E8C60F6B}"/>
               </a:ext>
             </a:extLst>
           </p:cNvPr>
@@ -9358,7 +9493,7 @@
           <p:cNvPr id="53" name="Rounded Rectangle 52">
             <a:extLst>
               <a:ext uri="{FF2B5EF4-FFF2-40B4-BE49-F238E27FC236}">
-                <a16:creationId xmlns:a16="http://schemas.microsoft.com/office/drawing/2014/main" id="{F7C47324-E020-954D-8637-268BFD1E7883}"/>
+                <a16:creationId xmlns:a16="http://schemas.microsoft.com/office/drawing/2014/main" id="{C78C7411-F48B-0DB8-116F-E88CDBFBF84A}"/>
               </a:ext>
             </a:extLst>
           </p:cNvPr>
@@ -9437,7 +9572,7 @@
           <p:cNvPr id="76" name="Elbow Connector 75">
             <a:extLst>
               <a:ext uri="{FF2B5EF4-FFF2-40B4-BE49-F238E27FC236}">
-                <a16:creationId xmlns:a16="http://schemas.microsoft.com/office/drawing/2014/main" id="{E605485B-D8A0-2E4E-9FCA-3310D536932D}"/>
+                <a16:creationId xmlns:a16="http://schemas.microsoft.com/office/drawing/2014/main" id="{073D319B-B7E0-F065-8F3F-4D009FD79D39}"/>
               </a:ext>
             </a:extLst>
           </p:cNvPr>
@@ -9482,7 +9617,7 @@
           <p:cNvPr id="79" name="Elbow Connector 78">
             <a:extLst>
               <a:ext uri="{FF2B5EF4-FFF2-40B4-BE49-F238E27FC236}">
-                <a16:creationId xmlns:a16="http://schemas.microsoft.com/office/drawing/2014/main" id="{2B2B2CF2-ECEE-784A-A272-972A92C7B960}"/>
+                <a16:creationId xmlns:a16="http://schemas.microsoft.com/office/drawing/2014/main" id="{7BAC6956-9720-3ECB-C357-99B69407B4EC}"/>
               </a:ext>
             </a:extLst>
           </p:cNvPr>
@@ -9527,7 +9662,7 @@
           <p:cNvPr id="83" name="Elbow Connector 82">
             <a:extLst>
               <a:ext uri="{FF2B5EF4-FFF2-40B4-BE49-F238E27FC236}">
-                <a16:creationId xmlns:a16="http://schemas.microsoft.com/office/drawing/2014/main" id="{0F24C1CF-CB18-9F45-A784-B83E40508CF7}"/>
+                <a16:creationId xmlns:a16="http://schemas.microsoft.com/office/drawing/2014/main" id="{6CEB3BF1-A274-DF61-8396-62FA8C6D1CF2}"/>
               </a:ext>
             </a:extLst>
           </p:cNvPr>
@@ -9572,7 +9707,7 @@
           <p:cNvPr id="90" name="Elbow Connector 89">
             <a:extLst>
               <a:ext uri="{FF2B5EF4-FFF2-40B4-BE49-F238E27FC236}">
-                <a16:creationId xmlns:a16="http://schemas.microsoft.com/office/drawing/2014/main" id="{A41159FF-9E8F-FB44-8E88-8F560F3F3E4B}"/>
+                <a16:creationId xmlns:a16="http://schemas.microsoft.com/office/drawing/2014/main" id="{F5A4D66B-222D-DD66-5F50-F107FB1CB3A2}"/>
               </a:ext>
             </a:extLst>
           </p:cNvPr>
@@ -9617,7 +9752,7 @@
           <p:cNvPr id="93" name="Elbow Connector 92">
             <a:extLst>
               <a:ext uri="{FF2B5EF4-FFF2-40B4-BE49-F238E27FC236}">
-                <a16:creationId xmlns:a16="http://schemas.microsoft.com/office/drawing/2014/main" id="{CF8CE418-5EB2-3942-94E2-3A107E9D380E}"/>
+                <a16:creationId xmlns:a16="http://schemas.microsoft.com/office/drawing/2014/main" id="{420CCCD7-3F6B-79B5-26BF-9997D3086A4A}"/>
               </a:ext>
             </a:extLst>
           </p:cNvPr>
@@ -9662,7 +9797,7 @@
           <p:cNvPr id="100" name="Elbow Connector 99">
             <a:extLst>
               <a:ext uri="{FF2B5EF4-FFF2-40B4-BE49-F238E27FC236}">
-                <a16:creationId xmlns:a16="http://schemas.microsoft.com/office/drawing/2014/main" id="{D8E89D82-B8DD-144B-9FD2-FD0FB0FC43D1}"/>
+                <a16:creationId xmlns:a16="http://schemas.microsoft.com/office/drawing/2014/main" id="{EC55B929-308E-C3AA-6342-D03D5D8D53ED}"/>
               </a:ext>
             </a:extLst>
           </p:cNvPr>
@@ -9707,7 +9842,7 @@
           <p:cNvPr id="103" name="Elbow Connector 102">
             <a:extLst>
               <a:ext uri="{FF2B5EF4-FFF2-40B4-BE49-F238E27FC236}">
-                <a16:creationId xmlns:a16="http://schemas.microsoft.com/office/drawing/2014/main" id="{04F129E3-B788-244E-A849-D7B31002492C}"/>
+                <a16:creationId xmlns:a16="http://schemas.microsoft.com/office/drawing/2014/main" id="{ED2DD0F2-E1B7-202E-FAB2-8F4A7559F97E}"/>
               </a:ext>
             </a:extLst>
           </p:cNvPr>
@@ -9752,7 +9887,7 @@
           <p:cNvPr id="110" name="Elbow Connector 109">
             <a:extLst>
               <a:ext uri="{FF2B5EF4-FFF2-40B4-BE49-F238E27FC236}">
-                <a16:creationId xmlns:a16="http://schemas.microsoft.com/office/drawing/2014/main" id="{147BB885-DE33-5445-A31F-38F5A547729F}"/>
+                <a16:creationId xmlns:a16="http://schemas.microsoft.com/office/drawing/2014/main" id="{B765D618-77AE-73AA-2D1C-91ED9A703640}"/>
               </a:ext>
             </a:extLst>
           </p:cNvPr>
@@ -9797,7 +9932,7 @@
           <p:cNvPr id="114" name="Elbow Connector 113">
             <a:extLst>
               <a:ext uri="{FF2B5EF4-FFF2-40B4-BE49-F238E27FC236}">
-                <a16:creationId xmlns:a16="http://schemas.microsoft.com/office/drawing/2014/main" id="{B96E0E4B-EAD1-A043-B18B-276171EA8A93}"/>
+                <a16:creationId xmlns:a16="http://schemas.microsoft.com/office/drawing/2014/main" id="{598A7B73-6300-20B9-DC2D-72E9BD9CF25D}"/>
               </a:ext>
             </a:extLst>
           </p:cNvPr>
@@ -9842,7 +9977,7 @@
           <p:cNvPr id="119" name="Elbow Connector 118">
             <a:extLst>
               <a:ext uri="{FF2B5EF4-FFF2-40B4-BE49-F238E27FC236}">
-                <a16:creationId xmlns:a16="http://schemas.microsoft.com/office/drawing/2014/main" id="{C2E7381A-4900-BC4A-A618-6D7F8821BE3B}"/>
+                <a16:creationId xmlns:a16="http://schemas.microsoft.com/office/drawing/2014/main" id="{5125374F-01AB-C574-804C-1CBE5799BE42}"/>
               </a:ext>
             </a:extLst>
           </p:cNvPr>
@@ -9887,7 +10022,7 @@
           <p:cNvPr id="140" name="Elbow Connector 139">
             <a:extLst>
               <a:ext uri="{FF2B5EF4-FFF2-40B4-BE49-F238E27FC236}">
-                <a16:creationId xmlns:a16="http://schemas.microsoft.com/office/drawing/2014/main" id="{1B97B39F-CA19-AE43-AB61-06CCF83C43D3}"/>
+                <a16:creationId xmlns:a16="http://schemas.microsoft.com/office/drawing/2014/main" id="{A704C870-918E-C374-EE09-C7516CF04355}"/>
               </a:ext>
             </a:extLst>
           </p:cNvPr>
@@ -9931,7 +10066,7 @@
           <p:cNvPr id="143" name="Elbow Connector 142">
             <a:extLst>
               <a:ext uri="{FF2B5EF4-FFF2-40B4-BE49-F238E27FC236}">
-                <a16:creationId xmlns:a16="http://schemas.microsoft.com/office/drawing/2014/main" id="{BD3352D0-D7D6-EB4A-B6C3-46F7B68AF5F5}"/>
+                <a16:creationId xmlns:a16="http://schemas.microsoft.com/office/drawing/2014/main" id="{EEB0CAFC-C14D-16B9-D7E0-F55FB56C2582}"/>
               </a:ext>
             </a:extLst>
           </p:cNvPr>
@@ -9977,7 +10112,7 @@
           <p:cNvPr id="67" name="Rounded Rectangle 66">
             <a:extLst>
               <a:ext uri="{FF2B5EF4-FFF2-40B4-BE49-F238E27FC236}">
-                <a16:creationId xmlns:a16="http://schemas.microsoft.com/office/drawing/2014/main" id="{29D7D188-8CCC-954E-804B-6611A99A8F65}"/>
+                <a16:creationId xmlns:a16="http://schemas.microsoft.com/office/drawing/2014/main" id="{BC92F2D7-6B02-76CC-58EB-8384FAB835D3}"/>
               </a:ext>
             </a:extLst>
           </p:cNvPr>
@@ -10055,7 +10190,7 @@
           <p:cNvPr id="35" name="Group 34">
             <a:extLst>
               <a:ext uri="{FF2B5EF4-FFF2-40B4-BE49-F238E27FC236}">
-                <a16:creationId xmlns:a16="http://schemas.microsoft.com/office/drawing/2014/main" id="{AB7C5F76-F89C-7C4C-813A-606E79B51BB4}"/>
+                <a16:creationId xmlns:a16="http://schemas.microsoft.com/office/drawing/2014/main" id="{E523FE2B-B257-30FB-9A7D-07056729C0E6}"/>
               </a:ext>
             </a:extLst>
           </p:cNvPr>
@@ -10075,7 +10210,7 @@
             <p:cNvPr id="154" name="Rounded Rectangle 153">
               <a:extLst>
                 <a:ext uri="{FF2B5EF4-FFF2-40B4-BE49-F238E27FC236}">
-                  <a16:creationId xmlns:a16="http://schemas.microsoft.com/office/drawing/2014/main" id="{68186602-AD2A-014E-AD39-10A2A3E16FF9}"/>
+                  <a16:creationId xmlns:a16="http://schemas.microsoft.com/office/drawing/2014/main" id="{84955E90-33F7-D377-D461-05A0CE3C7DF9}"/>
                 </a:ext>
               </a:extLst>
             </p:cNvPr>
@@ -10139,7 +10274,7 @@
             <p:cNvPr id="155" name="Rounded Rectangle 154">
               <a:extLst>
                 <a:ext uri="{FF2B5EF4-FFF2-40B4-BE49-F238E27FC236}">
-                  <a16:creationId xmlns:a16="http://schemas.microsoft.com/office/drawing/2014/main" id="{6257EBBA-EA04-7F46-98D0-5176746D6B7B}"/>
+                  <a16:creationId xmlns:a16="http://schemas.microsoft.com/office/drawing/2014/main" id="{AD5C285D-6F29-D0E3-ECC8-EE845C63A0CB}"/>
                 </a:ext>
               </a:extLst>
             </p:cNvPr>
@@ -10217,7 +10352,7 @@
             <p:cNvPr id="156" name="Rectangle 155">
               <a:extLst>
                 <a:ext uri="{FF2B5EF4-FFF2-40B4-BE49-F238E27FC236}">
-                  <a16:creationId xmlns:a16="http://schemas.microsoft.com/office/drawing/2014/main" id="{10BCE01A-DBB3-9143-A893-F1E0C97C1020}"/>
+                  <a16:creationId xmlns:a16="http://schemas.microsoft.com/office/drawing/2014/main" id="{747E4D18-A3BC-A147-548A-03F87933351D}"/>
                 </a:ext>
               </a:extLst>
             </p:cNvPr>
@@ -10299,7 +10434,7 @@
             <p:cNvPr id="78" name="Rounded Rectangle 77">
               <a:extLst>
                 <a:ext uri="{FF2B5EF4-FFF2-40B4-BE49-F238E27FC236}">
-                  <a16:creationId xmlns:a16="http://schemas.microsoft.com/office/drawing/2014/main" id="{47BC7222-CA9E-1941-85E8-926FC959071C}"/>
+                  <a16:creationId xmlns:a16="http://schemas.microsoft.com/office/drawing/2014/main" id="{596C608B-FBE7-6DAE-F413-CCE58003508D}"/>
                 </a:ext>
               </a:extLst>
             </p:cNvPr>
@@ -10378,7 +10513,7 @@
           <p:cNvPr id="80" name="Rounded Rectangle 79">
             <a:extLst>
               <a:ext uri="{FF2B5EF4-FFF2-40B4-BE49-F238E27FC236}">
-                <a16:creationId xmlns:a16="http://schemas.microsoft.com/office/drawing/2014/main" id="{3B6E1E3C-F44D-704A-89B0-755B1E344DAD}"/>
+                <a16:creationId xmlns:a16="http://schemas.microsoft.com/office/drawing/2014/main" id="{C9031BBA-32EF-7B57-9EAD-86E57603B5AB}"/>
               </a:ext>
             </a:extLst>
           </p:cNvPr>
@@ -10456,7 +10591,7 @@
           <p:cNvPr id="84" name="Rounded Rectangle 83">
             <a:extLst>
               <a:ext uri="{FF2B5EF4-FFF2-40B4-BE49-F238E27FC236}">
-                <a16:creationId xmlns:a16="http://schemas.microsoft.com/office/drawing/2014/main" id="{732FD824-3E7B-7C42-B9D1-19A8004EA454}"/>
+                <a16:creationId xmlns:a16="http://schemas.microsoft.com/office/drawing/2014/main" id="{AED1577D-5787-6923-B754-1CE02508AAA7}"/>
               </a:ext>
             </a:extLst>
           </p:cNvPr>
@@ -10535,7 +10670,7 @@
           <p:cNvPr id="85" name="Rounded Rectangle 84">
             <a:extLst>
               <a:ext uri="{FF2B5EF4-FFF2-40B4-BE49-F238E27FC236}">
-                <a16:creationId xmlns:a16="http://schemas.microsoft.com/office/drawing/2014/main" id="{97107E32-BFD3-864B-9341-D08C6D27262C}"/>
+                <a16:creationId xmlns:a16="http://schemas.microsoft.com/office/drawing/2014/main" id="{50FDC78F-B91A-5351-A1E9-A32795766E9A}"/>
               </a:ext>
             </a:extLst>
           </p:cNvPr>
@@ -10613,7 +10748,7 @@
           <p:cNvPr id="86" name="Rounded Rectangle 85">
             <a:extLst>
               <a:ext uri="{FF2B5EF4-FFF2-40B4-BE49-F238E27FC236}">
-                <a16:creationId xmlns:a16="http://schemas.microsoft.com/office/drawing/2014/main" id="{CE03D340-C9EC-A74E-90F9-2749DE85D293}"/>
+                <a16:creationId xmlns:a16="http://schemas.microsoft.com/office/drawing/2014/main" id="{67793D5F-4CAA-D1B2-59D2-65F099B58DFF}"/>
               </a:ext>
             </a:extLst>
           </p:cNvPr>
@@ -10691,7 +10826,7 @@
           <p:cNvPr id="95" name="Rounded Rectangle 94">
             <a:extLst>
               <a:ext uri="{FF2B5EF4-FFF2-40B4-BE49-F238E27FC236}">
-                <a16:creationId xmlns:a16="http://schemas.microsoft.com/office/drawing/2014/main" id="{0ABEBD32-8D80-2A4B-8E9A-A493A0E0F20A}"/>
+                <a16:creationId xmlns:a16="http://schemas.microsoft.com/office/drawing/2014/main" id="{DAB8092C-B00F-9423-5845-DF7741549A6D}"/>
               </a:ext>
             </a:extLst>
           </p:cNvPr>
@@ -10769,7 +10904,7 @@
           <p:cNvPr id="96" name="Elbow Connector 95">
             <a:extLst>
               <a:ext uri="{FF2B5EF4-FFF2-40B4-BE49-F238E27FC236}">
-                <a16:creationId xmlns:a16="http://schemas.microsoft.com/office/drawing/2014/main" id="{CA4692CA-901A-3A4C-B46A-FAABFF0AB97D}"/>
+                <a16:creationId xmlns:a16="http://schemas.microsoft.com/office/drawing/2014/main" id="{F7A1AFF0-EC63-6539-BA4C-B507A092FC84}"/>
               </a:ext>
             </a:extLst>
           </p:cNvPr>
@@ -10814,7 +10949,7 @@
           <p:cNvPr id="102" name="Rounded Rectangle 101">
             <a:extLst>
               <a:ext uri="{FF2B5EF4-FFF2-40B4-BE49-F238E27FC236}">
-                <a16:creationId xmlns:a16="http://schemas.microsoft.com/office/drawing/2014/main" id="{902D2B7A-CC15-6D42-948A-F1ECEEB0FBD9}"/>
+                <a16:creationId xmlns:a16="http://schemas.microsoft.com/office/drawing/2014/main" id="{D0E6B33F-6299-1576-790E-96B3A9A92A21}"/>
               </a:ext>
             </a:extLst>
           </p:cNvPr>
@@ -10892,7 +11027,7 @@
           <p:cNvPr id="104" name="Rounded Rectangle 103">
             <a:extLst>
               <a:ext uri="{FF2B5EF4-FFF2-40B4-BE49-F238E27FC236}">
-                <a16:creationId xmlns:a16="http://schemas.microsoft.com/office/drawing/2014/main" id="{368A3688-E1C6-8846-A038-A6E332535C8E}"/>
+                <a16:creationId xmlns:a16="http://schemas.microsoft.com/office/drawing/2014/main" id="{A0278CF8-5A41-D50C-B1F4-706D333AB1DE}"/>
               </a:ext>
             </a:extLst>
           </p:cNvPr>
@@ -10970,7 +11105,7 @@
           <p:cNvPr id="106" name="Rounded Rectangle 105">
             <a:extLst>
               <a:ext uri="{FF2B5EF4-FFF2-40B4-BE49-F238E27FC236}">
-                <a16:creationId xmlns:a16="http://schemas.microsoft.com/office/drawing/2014/main" id="{84A8C87C-7F25-234B-B10D-C64B64D1CF8E}"/>
+                <a16:creationId xmlns:a16="http://schemas.microsoft.com/office/drawing/2014/main" id="{A4A0AEB8-40DB-58A4-1F90-3D97068E3D6F}"/>
               </a:ext>
             </a:extLst>
           </p:cNvPr>
@@ -11048,7 +11183,7 @@
           <p:cNvPr id="107" name="Rounded Rectangle 106">
             <a:extLst>
               <a:ext uri="{FF2B5EF4-FFF2-40B4-BE49-F238E27FC236}">
-                <a16:creationId xmlns:a16="http://schemas.microsoft.com/office/drawing/2014/main" id="{21C132D3-B377-D547-8957-E3EB59B0D929}"/>
+                <a16:creationId xmlns:a16="http://schemas.microsoft.com/office/drawing/2014/main" id="{E7942B74-39C4-73C2-6C72-4DFE188E8490}"/>
               </a:ext>
             </a:extLst>
           </p:cNvPr>
@@ -11126,7 +11261,7 @@
           <p:cNvPr id="108" name="Rounded Rectangle 107">
             <a:extLst>
               <a:ext uri="{FF2B5EF4-FFF2-40B4-BE49-F238E27FC236}">
-                <a16:creationId xmlns:a16="http://schemas.microsoft.com/office/drawing/2014/main" id="{9B7309DC-9046-B347-B713-8915877E4E19}"/>
+                <a16:creationId xmlns:a16="http://schemas.microsoft.com/office/drawing/2014/main" id="{60752663-6DF0-AA6E-B62A-5391F00ED5F8}"/>
               </a:ext>
             </a:extLst>
           </p:cNvPr>
@@ -11204,7 +11339,7 @@
           <p:cNvPr id="109" name="Rounded Rectangle 108">
             <a:extLst>
               <a:ext uri="{FF2B5EF4-FFF2-40B4-BE49-F238E27FC236}">
-                <a16:creationId xmlns:a16="http://schemas.microsoft.com/office/drawing/2014/main" id="{82D4422C-597E-314B-AADC-DCAA5DAD3852}"/>
+                <a16:creationId xmlns:a16="http://schemas.microsoft.com/office/drawing/2014/main" id="{B55FFA8F-74DB-3355-2D8E-DFC522B945CA}"/>
               </a:ext>
             </a:extLst>
           </p:cNvPr>
@@ -11283,7 +11418,7 @@
           <p:cNvPr id="111" name="Rounded Rectangle 110">
             <a:extLst>
               <a:ext uri="{FF2B5EF4-FFF2-40B4-BE49-F238E27FC236}">
-                <a16:creationId xmlns:a16="http://schemas.microsoft.com/office/drawing/2014/main" id="{A16ADAE3-096E-2A43-94CA-BF11EA4582F7}"/>
+                <a16:creationId xmlns:a16="http://schemas.microsoft.com/office/drawing/2014/main" id="{115F67A0-A9D0-AF91-5610-0469BC6799E8}"/>
               </a:ext>
             </a:extLst>
           </p:cNvPr>
@@ -11361,7 +11496,7 @@
           <p:cNvPr id="112" name="Rounded Rectangle 111">
             <a:extLst>
               <a:ext uri="{FF2B5EF4-FFF2-40B4-BE49-F238E27FC236}">
-                <a16:creationId xmlns:a16="http://schemas.microsoft.com/office/drawing/2014/main" id="{0F18CC42-D329-194C-AE4C-7279609B6F8D}"/>
+                <a16:creationId xmlns:a16="http://schemas.microsoft.com/office/drawing/2014/main" id="{086D1670-8B0A-82FA-18DE-EA6FCCB420D8}"/>
               </a:ext>
             </a:extLst>
           </p:cNvPr>
@@ -11439,7 +11574,7 @@
           <p:cNvPr id="113" name="Rounded Rectangle 112">
             <a:extLst>
               <a:ext uri="{FF2B5EF4-FFF2-40B4-BE49-F238E27FC236}">
-                <a16:creationId xmlns:a16="http://schemas.microsoft.com/office/drawing/2014/main" id="{EA940B7F-1D91-304B-9DA9-F2D13B53FED0}"/>
+                <a16:creationId xmlns:a16="http://schemas.microsoft.com/office/drawing/2014/main" id="{4D7A5AE0-98C6-743B-1A9E-4C7727E46503}"/>
               </a:ext>
             </a:extLst>
           </p:cNvPr>
@@ -11517,7 +11652,7 @@
           <p:cNvPr id="115" name="Rounded Rectangle 114">
             <a:extLst>
               <a:ext uri="{FF2B5EF4-FFF2-40B4-BE49-F238E27FC236}">
-                <a16:creationId xmlns:a16="http://schemas.microsoft.com/office/drawing/2014/main" id="{D8B42F9D-3061-7341-A6F9-52824B5D0CAD}"/>
+                <a16:creationId xmlns:a16="http://schemas.microsoft.com/office/drawing/2014/main" id="{1FEAFEB1-8E67-F79C-52A3-BAE6684E2CCD}"/>
               </a:ext>
             </a:extLst>
           </p:cNvPr>
@@ -11595,7 +11730,7 @@
           <p:cNvPr id="116" name="Rounded Rectangle 115">
             <a:extLst>
               <a:ext uri="{FF2B5EF4-FFF2-40B4-BE49-F238E27FC236}">
-                <a16:creationId xmlns:a16="http://schemas.microsoft.com/office/drawing/2014/main" id="{6683E200-6AD4-ED41-A0D1-F6538F2C834B}"/>
+                <a16:creationId xmlns:a16="http://schemas.microsoft.com/office/drawing/2014/main" id="{AC1100B3-2B3B-14C5-2A4D-EA2DE49290C2}"/>
               </a:ext>
             </a:extLst>
           </p:cNvPr>
@@ -11673,7 +11808,7 @@
           <p:cNvPr id="117" name="Elbow Connector 116">
             <a:extLst>
               <a:ext uri="{FF2B5EF4-FFF2-40B4-BE49-F238E27FC236}">
-                <a16:creationId xmlns:a16="http://schemas.microsoft.com/office/drawing/2014/main" id="{19694EA5-2A84-FD43-9F39-793DAF68A522}"/>
+                <a16:creationId xmlns:a16="http://schemas.microsoft.com/office/drawing/2014/main" id="{FAD87943-73D0-378D-EBFE-1E12C646E6A1}"/>
               </a:ext>
             </a:extLst>
           </p:cNvPr>
@@ -11718,7 +11853,7 @@
           <p:cNvPr id="120" name="Elbow Connector 119">
             <a:extLst>
               <a:ext uri="{FF2B5EF4-FFF2-40B4-BE49-F238E27FC236}">
-                <a16:creationId xmlns:a16="http://schemas.microsoft.com/office/drawing/2014/main" id="{2C8B8161-A436-CA4D-A82A-F50380633FDC}"/>
+                <a16:creationId xmlns:a16="http://schemas.microsoft.com/office/drawing/2014/main" id="{6E961C90-4C07-B82E-2323-4EDD1BCA6904}"/>
               </a:ext>
             </a:extLst>
           </p:cNvPr>
@@ -11763,7 +11898,7 @@
           <p:cNvPr id="134" name="Rounded Rectangle 133">
             <a:extLst>
               <a:ext uri="{FF2B5EF4-FFF2-40B4-BE49-F238E27FC236}">
-                <a16:creationId xmlns:a16="http://schemas.microsoft.com/office/drawing/2014/main" id="{C2F18FBC-41FB-E048-8B47-D40D3CB1ABCE}"/>
+                <a16:creationId xmlns:a16="http://schemas.microsoft.com/office/drawing/2014/main" id="{5297EE3D-3425-73F1-150D-987C0A17DF34}"/>
               </a:ext>
             </a:extLst>
           </p:cNvPr>
@@ -11841,7 +11976,7 @@
           <p:cNvPr id="141" name="Rounded Rectangle 140">
             <a:extLst>
               <a:ext uri="{FF2B5EF4-FFF2-40B4-BE49-F238E27FC236}">
-                <a16:creationId xmlns:a16="http://schemas.microsoft.com/office/drawing/2014/main" id="{6A6C2DC4-474B-BC44-8A77-88BB79C21F6E}"/>
+                <a16:creationId xmlns:a16="http://schemas.microsoft.com/office/drawing/2014/main" id="{5FCA1139-C8F5-1380-1753-49B8EF6E8B6D}"/>
               </a:ext>
             </a:extLst>
           </p:cNvPr>
@@ -11919,7 +12054,7 @@
           <p:cNvPr id="142" name="Rounded Rectangle 141">
             <a:extLst>
               <a:ext uri="{FF2B5EF4-FFF2-40B4-BE49-F238E27FC236}">
-                <a16:creationId xmlns:a16="http://schemas.microsoft.com/office/drawing/2014/main" id="{C8C83C6D-FB7D-7740-9710-8CC3FC917E06}"/>
+                <a16:creationId xmlns:a16="http://schemas.microsoft.com/office/drawing/2014/main" id="{C047D0F2-69CF-C52A-0246-17D5A3FAAE75}"/>
               </a:ext>
             </a:extLst>
           </p:cNvPr>
@@ -11991,7 +12126,7 @@
           <p:cNvPr id="144" name="Rounded Rectangle 143">
             <a:extLst>
               <a:ext uri="{FF2B5EF4-FFF2-40B4-BE49-F238E27FC236}">
-                <a16:creationId xmlns:a16="http://schemas.microsoft.com/office/drawing/2014/main" id="{C69DDB1C-9D98-4F48-8CB0-9B87CD483264}"/>
+                <a16:creationId xmlns:a16="http://schemas.microsoft.com/office/drawing/2014/main" id="{05A5C3F9-8B2D-9CAA-8A3A-7030943A2A9C}"/>
               </a:ext>
             </a:extLst>
           </p:cNvPr>
@@ -12081,7 +12216,7 @@
           <p:cNvPr id="145" name="Rounded Rectangle 144">
             <a:extLst>
               <a:ext uri="{FF2B5EF4-FFF2-40B4-BE49-F238E27FC236}">
-                <a16:creationId xmlns:a16="http://schemas.microsoft.com/office/drawing/2014/main" id="{A6C78812-7A86-F542-A81D-8A38FBB05F28}"/>
+                <a16:creationId xmlns:a16="http://schemas.microsoft.com/office/drawing/2014/main" id="{3DEBA5FA-E033-145A-5E9F-42CA49B45C30}"/>
               </a:ext>
             </a:extLst>
           </p:cNvPr>
@@ -12159,7 +12294,7 @@
           <p:cNvPr id="146" name="Rounded Rectangle 145">
             <a:extLst>
               <a:ext uri="{FF2B5EF4-FFF2-40B4-BE49-F238E27FC236}">
-                <a16:creationId xmlns:a16="http://schemas.microsoft.com/office/drawing/2014/main" id="{F9C81270-91A1-E148-A62E-83A2525F1A4B}"/>
+                <a16:creationId xmlns:a16="http://schemas.microsoft.com/office/drawing/2014/main" id="{04F0861B-83E6-E611-DAA4-FEBA161A6439}"/>
               </a:ext>
             </a:extLst>
           </p:cNvPr>
@@ -12238,7 +12373,7 @@
           <p:cNvPr id="148" name="Rounded Rectangle 147">
             <a:extLst>
               <a:ext uri="{FF2B5EF4-FFF2-40B4-BE49-F238E27FC236}">
-                <a16:creationId xmlns:a16="http://schemas.microsoft.com/office/drawing/2014/main" id="{F565E85D-BA72-3A42-9013-1D4C5F740249}"/>
+                <a16:creationId xmlns:a16="http://schemas.microsoft.com/office/drawing/2014/main" id="{8685F6D3-5CB7-6D82-BDF1-6CBC2007888C}"/>
               </a:ext>
             </a:extLst>
           </p:cNvPr>
@@ -12317,7 +12452,7 @@
           <p:cNvPr id="149" name="Rounded Rectangle 148">
             <a:extLst>
               <a:ext uri="{FF2B5EF4-FFF2-40B4-BE49-F238E27FC236}">
-                <a16:creationId xmlns:a16="http://schemas.microsoft.com/office/drawing/2014/main" id="{CC04198B-A5C1-3B46-AD8E-CC8A4D9A9138}"/>
+                <a16:creationId xmlns:a16="http://schemas.microsoft.com/office/drawing/2014/main" id="{615A4CFB-35CB-323A-0C14-B4187BB8AEDE}"/>
               </a:ext>
             </a:extLst>
           </p:cNvPr>
@@ -12395,7 +12530,7 @@
           <p:cNvPr id="151" name="Elbow Connector 150">
             <a:extLst>
               <a:ext uri="{FF2B5EF4-FFF2-40B4-BE49-F238E27FC236}">
-                <a16:creationId xmlns:a16="http://schemas.microsoft.com/office/drawing/2014/main" id="{564A9C00-E082-FF4A-B76E-800A9FE35FEA}"/>
+                <a16:creationId xmlns:a16="http://schemas.microsoft.com/office/drawing/2014/main" id="{D917E4E8-CDB0-C0CD-676B-9D6F1C8DFD36}"/>
               </a:ext>
             </a:extLst>
           </p:cNvPr>
@@ -12440,7 +12575,7 @@
           <p:cNvPr id="157" name="Rounded Rectangle 156">
             <a:extLst>
               <a:ext uri="{FF2B5EF4-FFF2-40B4-BE49-F238E27FC236}">
-                <a16:creationId xmlns:a16="http://schemas.microsoft.com/office/drawing/2014/main" id="{8C272F1D-0943-EA4F-B3BC-DFD50119FF5D}"/>
+                <a16:creationId xmlns:a16="http://schemas.microsoft.com/office/drawing/2014/main" id="{BE7F9B92-36C7-79A5-A272-F6AA16F3F2E5}"/>
               </a:ext>
             </a:extLst>
           </p:cNvPr>
@@ -12518,7 +12653,7 @@
           <p:cNvPr id="165" name="Rounded Rectangle 164">
             <a:extLst>
               <a:ext uri="{FF2B5EF4-FFF2-40B4-BE49-F238E27FC236}">
-                <a16:creationId xmlns:a16="http://schemas.microsoft.com/office/drawing/2014/main" id="{319C125B-8235-DE4E-AE09-7328BA338C9B}"/>
+                <a16:creationId xmlns:a16="http://schemas.microsoft.com/office/drawing/2014/main" id="{8B744354-FDA2-D861-0DA9-EA0853337A0C}"/>
               </a:ext>
             </a:extLst>
           </p:cNvPr>
@@ -12596,7 +12731,7 @@
           <p:cNvPr id="166" name="Rounded Rectangle 165">
             <a:extLst>
               <a:ext uri="{FF2B5EF4-FFF2-40B4-BE49-F238E27FC236}">
-                <a16:creationId xmlns:a16="http://schemas.microsoft.com/office/drawing/2014/main" id="{8536B49E-064A-534D-89E4-1B984EB709D7}"/>
+                <a16:creationId xmlns:a16="http://schemas.microsoft.com/office/drawing/2014/main" id="{7B0D61BC-AB45-A2E2-895B-635D17305E3F}"/>
               </a:ext>
             </a:extLst>
           </p:cNvPr>
@@ -12674,7 +12809,7 @@
           <p:cNvPr id="167" name="Rounded Rectangle 166">
             <a:extLst>
               <a:ext uri="{FF2B5EF4-FFF2-40B4-BE49-F238E27FC236}">
-                <a16:creationId xmlns:a16="http://schemas.microsoft.com/office/drawing/2014/main" id="{7AA22E22-D2C1-B741-9651-BD61435B5C73}"/>
+                <a16:creationId xmlns:a16="http://schemas.microsoft.com/office/drawing/2014/main" id="{1135920F-EFA8-2DD1-3C2A-1D07ECD34E1D}"/>
               </a:ext>
             </a:extLst>
           </p:cNvPr>
@@ -12752,7 +12887,7 @@
           <p:cNvPr id="173" name="Rounded Rectangle 172">
             <a:extLst>
               <a:ext uri="{FF2B5EF4-FFF2-40B4-BE49-F238E27FC236}">
-                <a16:creationId xmlns:a16="http://schemas.microsoft.com/office/drawing/2014/main" id="{6DBBC8FA-DA07-C849-AC84-81A8AC77F89F}"/>
+                <a16:creationId xmlns:a16="http://schemas.microsoft.com/office/drawing/2014/main" id="{042B3D19-9BAF-E514-80D2-5EDE4FA05582}"/>
               </a:ext>
             </a:extLst>
           </p:cNvPr>
@@ -12830,7 +12965,7 @@
           <p:cNvPr id="176" name="Rounded Rectangle 175">
             <a:extLst>
               <a:ext uri="{FF2B5EF4-FFF2-40B4-BE49-F238E27FC236}">
-                <a16:creationId xmlns:a16="http://schemas.microsoft.com/office/drawing/2014/main" id="{48A5A8C6-D27C-7845-8D73-D551E4D936AE}"/>
+                <a16:creationId xmlns:a16="http://schemas.microsoft.com/office/drawing/2014/main" id="{8E4521F5-8F54-A4B3-AC4D-1DAC34BD6527}"/>
               </a:ext>
             </a:extLst>
           </p:cNvPr>
@@ -12908,7 +13043,7 @@
           <p:cNvPr id="177" name="Rounded Rectangle 176">
             <a:extLst>
               <a:ext uri="{FF2B5EF4-FFF2-40B4-BE49-F238E27FC236}">
-                <a16:creationId xmlns:a16="http://schemas.microsoft.com/office/drawing/2014/main" id="{D99C8058-1E01-8049-A6B5-2C1D4B204798}"/>
+                <a16:creationId xmlns:a16="http://schemas.microsoft.com/office/drawing/2014/main" id="{6C8E18E8-6326-06AB-19E5-C6CEECFF75FA}"/>
               </a:ext>
             </a:extLst>
           </p:cNvPr>
@@ -12986,7 +13121,7 @@
           <p:cNvPr id="187" name="Elbow Connector 186">
             <a:extLst>
               <a:ext uri="{FF2B5EF4-FFF2-40B4-BE49-F238E27FC236}">
-                <a16:creationId xmlns:a16="http://schemas.microsoft.com/office/drawing/2014/main" id="{43489651-E858-2D42-96A7-B6BE4B5D1DB1}"/>
+                <a16:creationId xmlns:a16="http://schemas.microsoft.com/office/drawing/2014/main" id="{56A36235-4347-97B7-6467-235DF3DE5BC4}"/>
               </a:ext>
             </a:extLst>
           </p:cNvPr>
@@ -13032,7 +13167,7 @@
           <p:cNvPr id="195" name="Elbow Connector 194">
             <a:extLst>
               <a:ext uri="{FF2B5EF4-FFF2-40B4-BE49-F238E27FC236}">
-                <a16:creationId xmlns:a16="http://schemas.microsoft.com/office/drawing/2014/main" id="{1D7294FF-9018-EF4C-ABA0-3CEA75114B7E}"/>
+                <a16:creationId xmlns:a16="http://schemas.microsoft.com/office/drawing/2014/main" id="{E1B6E669-C859-E746-4C6F-508D0BD3BBC2}"/>
               </a:ext>
             </a:extLst>
           </p:cNvPr>
@@ -13078,7 +13213,7 @@
           <p:cNvPr id="198" name="Elbow Connector 197">
             <a:extLst>
               <a:ext uri="{FF2B5EF4-FFF2-40B4-BE49-F238E27FC236}">
-                <a16:creationId xmlns:a16="http://schemas.microsoft.com/office/drawing/2014/main" id="{1F8C024F-896D-4940-97BD-54696B1C8B85}"/>
+                <a16:creationId xmlns:a16="http://schemas.microsoft.com/office/drawing/2014/main" id="{8A7367DF-EDB0-EE97-FB4B-1CBAB04AAF34}"/>
               </a:ext>
             </a:extLst>
           </p:cNvPr>
@@ -13121,7 +13256,7 @@
           <p:cNvPr id="202" name="Elbow Connector 201">
             <a:extLst>
               <a:ext uri="{FF2B5EF4-FFF2-40B4-BE49-F238E27FC236}">
-                <a16:creationId xmlns:a16="http://schemas.microsoft.com/office/drawing/2014/main" id="{2CBB5579-C286-044A-A85B-FF3B96098A60}"/>
+                <a16:creationId xmlns:a16="http://schemas.microsoft.com/office/drawing/2014/main" id="{E37CB3E6-344D-CE06-079A-0EFEEE9F808B}"/>
               </a:ext>
             </a:extLst>
           </p:cNvPr>
@@ -13167,7 +13302,7 @@
           <p:cNvPr id="207" name="Elbow Connector 206">
             <a:extLst>
               <a:ext uri="{FF2B5EF4-FFF2-40B4-BE49-F238E27FC236}">
-                <a16:creationId xmlns:a16="http://schemas.microsoft.com/office/drawing/2014/main" id="{256AC07A-A1E1-8546-9393-6350BB5A3079}"/>
+                <a16:creationId xmlns:a16="http://schemas.microsoft.com/office/drawing/2014/main" id="{BD0E911E-D34C-1619-3E84-76E65E5C4599}"/>
               </a:ext>
             </a:extLst>
           </p:cNvPr>
@@ -13212,7 +13347,7 @@
           <p:cNvPr id="230" name="Elbow Connector 229">
             <a:extLst>
               <a:ext uri="{FF2B5EF4-FFF2-40B4-BE49-F238E27FC236}">
-                <a16:creationId xmlns:a16="http://schemas.microsoft.com/office/drawing/2014/main" id="{228A3DD1-6395-DE4B-925F-1D655D5FD11A}"/>
+                <a16:creationId xmlns:a16="http://schemas.microsoft.com/office/drawing/2014/main" id="{9918929B-DD51-15CD-8ECC-D6CF09E321BE}"/>
               </a:ext>
             </a:extLst>
           </p:cNvPr>
@@ -13258,7 +13393,7 @@
           <p:cNvPr id="256" name="Elbow Connector 255">
             <a:extLst>
               <a:ext uri="{FF2B5EF4-FFF2-40B4-BE49-F238E27FC236}">
-                <a16:creationId xmlns:a16="http://schemas.microsoft.com/office/drawing/2014/main" id="{B6108CFD-F123-194A-A1F1-80188928A0A6}"/>
+                <a16:creationId xmlns:a16="http://schemas.microsoft.com/office/drawing/2014/main" id="{C4234F0D-2E6C-86C3-6809-F2C2B4ABB33A}"/>
               </a:ext>
             </a:extLst>
           </p:cNvPr>
@@ -13303,7 +13438,7 @@
           <p:cNvPr id="274" name="Elbow Connector 273">
             <a:extLst>
               <a:ext uri="{FF2B5EF4-FFF2-40B4-BE49-F238E27FC236}">
-                <a16:creationId xmlns:a16="http://schemas.microsoft.com/office/drawing/2014/main" id="{DCE1F6EE-1651-2B44-9FC5-E884BB26E26E}"/>
+                <a16:creationId xmlns:a16="http://schemas.microsoft.com/office/drawing/2014/main" id="{DE517B3E-137A-9AAE-BD78-F6D2CB785868}"/>
               </a:ext>
             </a:extLst>
           </p:cNvPr>
@@ -13349,7 +13484,7 @@
           <p:cNvPr id="278" name="Elbow Connector 277">
             <a:extLst>
               <a:ext uri="{FF2B5EF4-FFF2-40B4-BE49-F238E27FC236}">
-                <a16:creationId xmlns:a16="http://schemas.microsoft.com/office/drawing/2014/main" id="{EC07CDE6-0428-B349-AA3F-163B9F8B9522}"/>
+                <a16:creationId xmlns:a16="http://schemas.microsoft.com/office/drawing/2014/main" id="{3F589261-78D4-9E63-4189-0621826DC6A5}"/>
               </a:ext>
             </a:extLst>
           </p:cNvPr>
@@ -13395,7 +13530,7 @@
           <p:cNvPr id="283" name="Elbow Connector 282">
             <a:extLst>
               <a:ext uri="{FF2B5EF4-FFF2-40B4-BE49-F238E27FC236}">
-                <a16:creationId xmlns:a16="http://schemas.microsoft.com/office/drawing/2014/main" id="{F65012B1-8420-2642-8CC7-DE808C5A279C}"/>
+                <a16:creationId xmlns:a16="http://schemas.microsoft.com/office/drawing/2014/main" id="{4F1E58C9-6345-9DED-AAB7-3C8A2FE4AEE4}"/>
               </a:ext>
             </a:extLst>
           </p:cNvPr>
@@ -13439,7 +13574,7 @@
           <p:cNvPr id="318" name="Elbow Connector 317">
             <a:extLst>
               <a:ext uri="{FF2B5EF4-FFF2-40B4-BE49-F238E27FC236}">
-                <a16:creationId xmlns:a16="http://schemas.microsoft.com/office/drawing/2014/main" id="{B329DC1F-A4D4-5146-8CF7-B2ADF5E81ED5}"/>
+                <a16:creationId xmlns:a16="http://schemas.microsoft.com/office/drawing/2014/main" id="{C1E6ECF5-99BD-3DBA-543C-4A18C18D1B11}"/>
               </a:ext>
             </a:extLst>
           </p:cNvPr>
@@ -13483,7 +13618,7 @@
           <p:cNvPr id="321" name="TextBox 320">
             <a:extLst>
               <a:ext uri="{FF2B5EF4-FFF2-40B4-BE49-F238E27FC236}">
-                <a16:creationId xmlns:a16="http://schemas.microsoft.com/office/drawing/2014/main" id="{FC347B98-7402-7F40-9733-A0912DA7C3C1}"/>
+                <a16:creationId xmlns:a16="http://schemas.microsoft.com/office/drawing/2014/main" id="{74B74E6C-10E7-D9B1-3F81-6BDEDC1E8252}"/>
               </a:ext>
             </a:extLst>
           </p:cNvPr>
@@ -13558,7 +13693,7 @@
           <p:cNvPr id="322" name="Elbow Connector 321">
             <a:extLst>
               <a:ext uri="{FF2B5EF4-FFF2-40B4-BE49-F238E27FC236}">
-                <a16:creationId xmlns:a16="http://schemas.microsoft.com/office/drawing/2014/main" id="{A934EA42-B256-FC4E-8968-D71FDB11AA16}"/>
+                <a16:creationId xmlns:a16="http://schemas.microsoft.com/office/drawing/2014/main" id="{02D0B1E9-6517-4316-1273-16BB3125CF59}"/>
               </a:ext>
             </a:extLst>
           </p:cNvPr>
@@ -13602,7 +13737,7 @@
           <p:cNvPr id="323" name="Elbow Connector 322">
             <a:extLst>
               <a:ext uri="{FF2B5EF4-FFF2-40B4-BE49-F238E27FC236}">
-                <a16:creationId xmlns:a16="http://schemas.microsoft.com/office/drawing/2014/main" id="{494FF44D-AC4B-304E-B3F9-48C82D1BCE3A}"/>
+                <a16:creationId xmlns:a16="http://schemas.microsoft.com/office/drawing/2014/main" id="{2A21C74F-565F-B008-B8B3-24C5509BCEF8}"/>
               </a:ext>
             </a:extLst>
           </p:cNvPr>
@@ -13648,7 +13783,7 @@
           <p:cNvPr id="327" name="Elbow Connector 326">
             <a:extLst>
               <a:ext uri="{FF2B5EF4-FFF2-40B4-BE49-F238E27FC236}">
-                <a16:creationId xmlns:a16="http://schemas.microsoft.com/office/drawing/2014/main" id="{0C459651-B45D-B84F-BDD6-C30A7A6FBEC3}"/>
+                <a16:creationId xmlns:a16="http://schemas.microsoft.com/office/drawing/2014/main" id="{48B07C54-889C-0352-0189-7D1147FFF2A7}"/>
               </a:ext>
             </a:extLst>
           </p:cNvPr>
@@ -13693,7 +13828,7 @@
           <p:cNvPr id="334" name="Elbow Connector 333">
             <a:extLst>
               <a:ext uri="{FF2B5EF4-FFF2-40B4-BE49-F238E27FC236}">
-                <a16:creationId xmlns:a16="http://schemas.microsoft.com/office/drawing/2014/main" id="{3701092A-DF69-8E49-95EA-16C67BBBFBF1}"/>
+                <a16:creationId xmlns:a16="http://schemas.microsoft.com/office/drawing/2014/main" id="{8783DCD2-1A64-E617-1F32-6F60F2380E15}"/>
               </a:ext>
             </a:extLst>
           </p:cNvPr>
@@ -13738,7 +13873,7 @@
           <p:cNvPr id="337" name="Elbow Connector 336">
             <a:extLst>
               <a:ext uri="{FF2B5EF4-FFF2-40B4-BE49-F238E27FC236}">
-                <a16:creationId xmlns:a16="http://schemas.microsoft.com/office/drawing/2014/main" id="{78159B24-AEE3-374C-93E9-622915D5A813}"/>
+                <a16:creationId xmlns:a16="http://schemas.microsoft.com/office/drawing/2014/main" id="{F1FC6EA2-7358-C28F-3711-5AF48BCA42CC}"/>
               </a:ext>
             </a:extLst>
           </p:cNvPr>
@@ -13784,7 +13919,7 @@
           <p:cNvPr id="342" name="Elbow Connector 341">
             <a:extLst>
               <a:ext uri="{FF2B5EF4-FFF2-40B4-BE49-F238E27FC236}">
-                <a16:creationId xmlns:a16="http://schemas.microsoft.com/office/drawing/2014/main" id="{8233F3F1-5C89-1642-92B4-A73ADAB5D7DF}"/>
+                <a16:creationId xmlns:a16="http://schemas.microsoft.com/office/drawing/2014/main" id="{18047503-A28C-3124-D1CB-F3DFC8401CA1}"/>
               </a:ext>
             </a:extLst>
           </p:cNvPr>
@@ -13829,7 +13964,7 @@
           <p:cNvPr id="382" name="Elbow Connector 381">
             <a:extLst>
               <a:ext uri="{FF2B5EF4-FFF2-40B4-BE49-F238E27FC236}">
-                <a16:creationId xmlns:a16="http://schemas.microsoft.com/office/drawing/2014/main" id="{A2350599-D3A1-2640-9A43-A7AC71D66B78}"/>
+                <a16:creationId xmlns:a16="http://schemas.microsoft.com/office/drawing/2014/main" id="{658ADCC9-FC04-62D2-8A7F-98FA2E67566D}"/>
               </a:ext>
             </a:extLst>
           </p:cNvPr>
@@ -13874,7 +14009,7 @@
           <p:cNvPr id="385" name="Elbow Connector 384">
             <a:extLst>
               <a:ext uri="{FF2B5EF4-FFF2-40B4-BE49-F238E27FC236}">
-                <a16:creationId xmlns:a16="http://schemas.microsoft.com/office/drawing/2014/main" id="{5672611D-601D-F047-8E81-AB13C0DAD742}"/>
+                <a16:creationId xmlns:a16="http://schemas.microsoft.com/office/drawing/2014/main" id="{603D3E05-0DA0-E243-DB78-2F8C4E6FDD37}"/>
               </a:ext>
             </a:extLst>
           </p:cNvPr>
@@ -13919,7 +14054,7 @@
           <p:cNvPr id="448" name="Elbow Connector 447">
             <a:extLst>
               <a:ext uri="{FF2B5EF4-FFF2-40B4-BE49-F238E27FC236}">
-                <a16:creationId xmlns:a16="http://schemas.microsoft.com/office/drawing/2014/main" id="{4A1E0B6E-4AAB-674C-BC7A-8904AF7D82F9}"/>
+                <a16:creationId xmlns:a16="http://schemas.microsoft.com/office/drawing/2014/main" id="{E3775DAE-72CD-A08E-6122-93632070CA85}"/>
               </a:ext>
             </a:extLst>
           </p:cNvPr>
@@ -13964,7 +14099,7 @@
           <p:cNvPr id="4" name="Rounded Rectangle 3">
             <a:extLst>
               <a:ext uri="{FF2B5EF4-FFF2-40B4-BE49-F238E27FC236}">
-                <a16:creationId xmlns:a16="http://schemas.microsoft.com/office/drawing/2014/main" id="{CE87A59E-1D64-3F63-9A6C-ABB405326E10}"/>
+                <a16:creationId xmlns:a16="http://schemas.microsoft.com/office/drawing/2014/main" id="{C66426E9-0E7D-3D81-16F8-4ADDB3C0615C}"/>
               </a:ext>
             </a:extLst>
           </p:cNvPr>
@@ -14019,7 +14154,7 @@
           <p:cNvPr id="6" name="Rounded Rectangle 5">
             <a:extLst>
               <a:ext uri="{FF2B5EF4-FFF2-40B4-BE49-F238E27FC236}">
-                <a16:creationId xmlns:a16="http://schemas.microsoft.com/office/drawing/2014/main" id="{6FFA7931-F2F9-8EA3-375A-7C04E7DFED3C}"/>
+                <a16:creationId xmlns:a16="http://schemas.microsoft.com/office/drawing/2014/main" id="{6E128F6D-0581-3485-680F-BB8F2CBC53C0}"/>
               </a:ext>
             </a:extLst>
           </p:cNvPr>
@@ -14091,7 +14226,7 @@
           <p:cNvPr id="2" name="TextBox 1">
             <a:extLst>
               <a:ext uri="{FF2B5EF4-FFF2-40B4-BE49-F238E27FC236}">
-                <a16:creationId xmlns:a16="http://schemas.microsoft.com/office/drawing/2014/main" id="{C66F64B8-6A07-59ED-97FC-F372E16B24A8}"/>
+                <a16:creationId xmlns:a16="http://schemas.microsoft.com/office/drawing/2014/main" id="{1F48243F-407A-2BDD-4850-F4DAA06E4184}"/>
               </a:ext>
             </a:extLst>
           </p:cNvPr>
@@ -14101,7 +14236,7 @@
         <p:spPr>
           <a:xfrm>
             <a:off x="380116" y="260967"/>
-            <a:ext cx="4789076" cy="461665"/>
+            <a:ext cx="4789076" cy="830997"/>
           </a:xfrm>
           <a:prstGeom prst="rect">
             <a:avLst/>
@@ -14121,6 +14256,19 @@
               </a:rPr>
               <a:t>AngstromCube/a43</a:t>
             </a:r>
+            <a:br>
+              <a:rPr lang="en-DE" sz="2400" b="1" dirty="0">
+                <a:latin typeface="Courier New" panose="02070309020205020404" pitchFamily="49" charset="0"/>
+                <a:cs typeface="Courier New" panose="02070309020205020404" pitchFamily="49" charset="0"/>
+              </a:rPr>
+            </a:br>
+            <a:r>
+              <a:rPr lang="en-DE" sz="2400" b="1" dirty="0">
+                <a:latin typeface="Courier New" panose="02070309020205020404" pitchFamily="49" charset="0"/>
+                <a:cs typeface="Courier New" panose="02070309020205020404" pitchFamily="49" charset="0"/>
+              </a:rPr>
+              <a:t>DataFlow</a:t>
+            </a:r>
           </a:p>
         </p:txBody>
       </p:sp>
@@ -14129,7 +14277,7 @@
           <p:cNvPr id="7" name="Rounded Rectangle 6">
             <a:extLst>
               <a:ext uri="{FF2B5EF4-FFF2-40B4-BE49-F238E27FC236}">
-                <a16:creationId xmlns:a16="http://schemas.microsoft.com/office/drawing/2014/main" id="{C454EC76-62D4-DA50-0000-5DB0289CCED4}"/>
+                <a16:creationId xmlns:a16="http://schemas.microsoft.com/office/drawing/2014/main" id="{7476EDEE-17F3-577E-D41C-CB78C06FE119}"/>
               </a:ext>
             </a:extLst>
           </p:cNvPr>
@@ -14207,7 +14355,7 @@
           <p:cNvPr id="9" name="Elbow Connector 8">
             <a:extLst>
               <a:ext uri="{FF2B5EF4-FFF2-40B4-BE49-F238E27FC236}">
-                <a16:creationId xmlns:a16="http://schemas.microsoft.com/office/drawing/2014/main" id="{E4632847-6BC0-384C-5075-416406704D2A}"/>
+                <a16:creationId xmlns:a16="http://schemas.microsoft.com/office/drawing/2014/main" id="{40B08CBF-0BA5-EE8E-5119-094E1538F235}"/>
               </a:ext>
             </a:extLst>
           </p:cNvPr>
@@ -14250,7 +14398,7 @@
     </p:spTree>
     <p:extLst>
       <p:ext uri="{BB962C8B-B14F-4D97-AF65-F5344CB8AC3E}">
-        <p14:creationId xmlns:p14="http://schemas.microsoft.com/office/powerpoint/2010/main" val="553252380"/>
+        <p14:creationId xmlns:p14="http://schemas.microsoft.com/office/powerpoint/2010/main" val="493698078"/>
       </p:ext>
     </p:extLst>
   </p:cSld>
@@ -14265,7 +14413,13 @@
   <p:cSld>
     <p:spTree>
       <p:nvGrpSpPr>
-        <p:cNvPr id="1" name=""/>
+        <p:cNvPr id="1" name="">
+          <a:extLst>
+            <a:ext uri="{FF2B5EF4-FFF2-40B4-BE49-F238E27FC236}">
+              <a16:creationId xmlns:a16="http://schemas.microsoft.com/office/drawing/2014/main" id="{E7EF252F-4E3D-DF6A-FD58-B550FCF81491}"/>
+            </a:ext>
+          </a:extLst>
+        </p:cNvPr>
         <p:cNvGrpSpPr/>
         <p:nvPr/>
       </p:nvGrpSpPr>
@@ -14282,7 +14436,7 @@
           <p:cNvPr id="381" name="Rectangle 380">
             <a:extLst>
               <a:ext uri="{FF2B5EF4-FFF2-40B4-BE49-F238E27FC236}">
-                <a16:creationId xmlns:a16="http://schemas.microsoft.com/office/drawing/2014/main" id="{5A95D46E-86C0-7C41-9B33-C47148B06BC4}"/>
+                <a16:creationId xmlns:a16="http://schemas.microsoft.com/office/drawing/2014/main" id="{E162706B-B583-FFA0-D0D3-ADE33A9D4CC1}"/>
               </a:ext>
             </a:extLst>
           </p:cNvPr>
@@ -14371,7 +14525,7 @@
           <p:cNvPr id="5" name="Picture 4">
             <a:extLst>
               <a:ext uri="{FF2B5EF4-FFF2-40B4-BE49-F238E27FC236}">
-                <a16:creationId xmlns:a16="http://schemas.microsoft.com/office/drawing/2014/main" id="{55738121-16F2-BA4C-9405-759F95BDB794}"/>
+                <a16:creationId xmlns:a16="http://schemas.microsoft.com/office/drawing/2014/main" id="{EF5EA02D-86EC-D398-E085-3EE7629BC893}"/>
               </a:ext>
             </a:extLst>
           </p:cNvPr>
@@ -14401,7 +14555,7 @@
           <p:cNvPr id="11" name="Rounded Rectangle 10">
             <a:extLst>
               <a:ext uri="{FF2B5EF4-FFF2-40B4-BE49-F238E27FC236}">
-                <a16:creationId xmlns:a16="http://schemas.microsoft.com/office/drawing/2014/main" id="{E0F7237A-5BD2-CE4B-AFE3-2FA12196F42B}"/>
+                <a16:creationId xmlns:a16="http://schemas.microsoft.com/office/drawing/2014/main" id="{60A642EE-903D-DA1E-1A07-2EEF6378A348}"/>
               </a:ext>
             </a:extLst>
           </p:cNvPr>
@@ -14479,7 +14633,7 @@
           <p:cNvPr id="12" name="Rounded Rectangle 11">
             <a:extLst>
               <a:ext uri="{FF2B5EF4-FFF2-40B4-BE49-F238E27FC236}">
-                <a16:creationId xmlns:a16="http://schemas.microsoft.com/office/drawing/2014/main" id="{CE154B7B-82F0-7549-9D5F-E41EA47F2C81}"/>
+                <a16:creationId xmlns:a16="http://schemas.microsoft.com/office/drawing/2014/main" id="{3670FBFF-B83A-FB63-36CE-33CD370B3A5C}"/>
               </a:ext>
             </a:extLst>
           </p:cNvPr>
@@ -14551,7 +14705,7 @@
           <p:cNvPr id="18" name="Group 17">
             <a:extLst>
               <a:ext uri="{FF2B5EF4-FFF2-40B4-BE49-F238E27FC236}">
-                <a16:creationId xmlns:a16="http://schemas.microsoft.com/office/drawing/2014/main" id="{CA89CFFD-1DBB-6543-81EC-4C388E067F44}"/>
+                <a16:creationId xmlns:a16="http://schemas.microsoft.com/office/drawing/2014/main" id="{893ACECD-DC41-C385-A8D7-46F950343BAB}"/>
               </a:ext>
             </a:extLst>
           </p:cNvPr>
@@ -14561,9 +14715,9 @@
         <p:grpSpPr>
           <a:xfrm>
             <a:off x="11012850" y="2269495"/>
-            <a:ext cx="1736763" cy="812800"/>
+            <a:ext cx="1836663" cy="812800"/>
             <a:chOff x="1186778" y="672706"/>
-            <a:chExt cx="1736763" cy="812800"/>
+            <a:chExt cx="1836663" cy="812800"/>
           </a:xfrm>
         </p:grpSpPr>
         <p:pic>
@@ -14571,7 +14725,7 @@
             <p:cNvPr id="14" name="Picture 13">
               <a:extLst>
                 <a:ext uri="{FF2B5EF4-FFF2-40B4-BE49-F238E27FC236}">
-                  <a16:creationId xmlns:a16="http://schemas.microsoft.com/office/drawing/2014/main" id="{09E502DF-15DF-CA4C-BCFE-F7ECBE069BA9}"/>
+                  <a16:creationId xmlns:a16="http://schemas.microsoft.com/office/drawing/2014/main" id="{C064A9F5-4256-1BEB-47B6-CAB6F7A2633E}"/>
                 </a:ext>
               </a:extLst>
             </p:cNvPr>
@@ -14603,7 +14757,7 @@
             <p:cNvPr id="17" name="TextBox 16">
               <a:extLst>
                 <a:ext uri="{FF2B5EF4-FFF2-40B4-BE49-F238E27FC236}">
-                  <a16:creationId xmlns:a16="http://schemas.microsoft.com/office/drawing/2014/main" id="{CF02BABB-4440-3345-8ECD-39B0A099AC1B}"/>
+                  <a16:creationId xmlns:a16="http://schemas.microsoft.com/office/drawing/2014/main" id="{EE7E425D-D10D-BD16-09C0-572398345355}"/>
                 </a:ext>
               </a:extLst>
             </p:cNvPr>
@@ -14613,7 +14767,7 @@
           <p:spPr>
             <a:xfrm>
               <a:off x="1902108" y="910908"/>
-              <a:ext cx="1021433" cy="461665"/>
+              <a:ext cx="1121333" cy="461665"/>
             </a:xfrm>
             <a:prstGeom prst="rect">
               <a:avLst/>
@@ -14627,16 +14781,12 @@
             <a:lstStyle/>
             <a:p>
               <a:r>
-                <a:rPr lang="de-DE" sz="1200" dirty="0" err="1"/>
-                <a:t>input</a:t>
-              </a:r>
-              <a:r>
                 <a:rPr lang="de-DE" sz="1200" dirty="0"/>
-                <a:t> </a:t>
+                <a:t>+</a:t>
               </a:r>
               <a:r>
                 <a:rPr lang="de-DE" sz="1200" dirty="0" err="1"/>
-                <a:t>file</a:t>
+                <a:t>geometry.file</a:t>
               </a:r>
               <a:endParaRPr lang="de-DE" sz="1200" dirty="0"/>
             </a:p>
@@ -14659,7 +14809,7 @@
           <p:cNvPr id="22" name="Rounded Rectangle 21">
             <a:extLst>
               <a:ext uri="{FF2B5EF4-FFF2-40B4-BE49-F238E27FC236}">
-                <a16:creationId xmlns:a16="http://schemas.microsoft.com/office/drawing/2014/main" id="{C46A3FE9-B3DC-1A40-8877-FEC5EEDAA212}"/>
+                <a16:creationId xmlns:a16="http://schemas.microsoft.com/office/drawing/2014/main" id="{8EB8EE58-F321-B0BB-1945-4BAF63252D6C}"/>
               </a:ext>
             </a:extLst>
           </p:cNvPr>
@@ -14737,7 +14887,7 @@
           <p:cNvPr id="26" name="Rounded Rectangle 25">
             <a:extLst>
               <a:ext uri="{FF2B5EF4-FFF2-40B4-BE49-F238E27FC236}">
-                <a16:creationId xmlns:a16="http://schemas.microsoft.com/office/drawing/2014/main" id="{6CD602C6-456F-C144-8760-5A3B06685886}"/>
+                <a16:creationId xmlns:a16="http://schemas.microsoft.com/office/drawing/2014/main" id="{A5D8797F-B793-F70A-DE71-AAEBBAC63357}"/>
               </a:ext>
             </a:extLst>
           </p:cNvPr>
@@ -14815,7 +14965,7 @@
           <p:cNvPr id="27" name="Rounded Rectangle 26">
             <a:extLst>
               <a:ext uri="{FF2B5EF4-FFF2-40B4-BE49-F238E27FC236}">
-                <a16:creationId xmlns:a16="http://schemas.microsoft.com/office/drawing/2014/main" id="{1D6E5ED0-21DE-9245-8DF0-0703B5C57762}"/>
+                <a16:creationId xmlns:a16="http://schemas.microsoft.com/office/drawing/2014/main" id="{67B97E7C-DFEC-7A3A-DC31-E9C0C5D3B900}"/>
               </a:ext>
             </a:extLst>
           </p:cNvPr>
@@ -14893,7 +15043,7 @@
           <p:cNvPr id="36" name="Rounded Rectangle 35">
             <a:extLst>
               <a:ext uri="{FF2B5EF4-FFF2-40B4-BE49-F238E27FC236}">
-                <a16:creationId xmlns:a16="http://schemas.microsoft.com/office/drawing/2014/main" id="{BFDA6D5C-B7DA-C241-B76D-C398410DD83F}"/>
+                <a16:creationId xmlns:a16="http://schemas.microsoft.com/office/drawing/2014/main" id="{D3B2A651-7ADE-D09D-DBCA-809C28416415}"/>
               </a:ext>
             </a:extLst>
           </p:cNvPr>
@@ -14972,7 +15122,7 @@
           <p:cNvPr id="37" name="Rounded Rectangle 36">
             <a:extLst>
               <a:ext uri="{FF2B5EF4-FFF2-40B4-BE49-F238E27FC236}">
-                <a16:creationId xmlns:a16="http://schemas.microsoft.com/office/drawing/2014/main" id="{0882E9FB-3DCD-5645-B675-E05F0BAA87E7}"/>
+                <a16:creationId xmlns:a16="http://schemas.microsoft.com/office/drawing/2014/main" id="{5EB6A9AF-55AE-E27A-7378-9300CCBDF7B4}"/>
               </a:ext>
             </a:extLst>
           </p:cNvPr>
@@ -15051,7 +15201,7 @@
           <p:cNvPr id="39" name="Rounded Rectangle 38">
             <a:extLst>
               <a:ext uri="{FF2B5EF4-FFF2-40B4-BE49-F238E27FC236}">
-                <a16:creationId xmlns:a16="http://schemas.microsoft.com/office/drawing/2014/main" id="{A735A9AE-E1F9-7C44-ACDD-90715307FAC0}"/>
+                <a16:creationId xmlns:a16="http://schemas.microsoft.com/office/drawing/2014/main" id="{5B6E9394-AB4C-7ED9-AE60-52EF6CAA5902}"/>
               </a:ext>
             </a:extLst>
           </p:cNvPr>
@@ -15130,7 +15280,7 @@
           <p:cNvPr id="44" name="Rounded Rectangle 43">
             <a:extLst>
               <a:ext uri="{FF2B5EF4-FFF2-40B4-BE49-F238E27FC236}">
-                <a16:creationId xmlns:a16="http://schemas.microsoft.com/office/drawing/2014/main" id="{5F26C983-CECD-9D4C-BB43-61181C7B1C14}"/>
+                <a16:creationId xmlns:a16="http://schemas.microsoft.com/office/drawing/2014/main" id="{CDBB3705-43C5-9914-40DC-471EA6F7E5DE}"/>
               </a:ext>
             </a:extLst>
           </p:cNvPr>
@@ -15208,7 +15358,7 @@
           <p:cNvPr id="53" name="Rounded Rectangle 52">
             <a:extLst>
               <a:ext uri="{FF2B5EF4-FFF2-40B4-BE49-F238E27FC236}">
-                <a16:creationId xmlns:a16="http://schemas.microsoft.com/office/drawing/2014/main" id="{F7C47324-E020-954D-8637-268BFD1E7883}"/>
+                <a16:creationId xmlns:a16="http://schemas.microsoft.com/office/drawing/2014/main" id="{7AE3EAFD-0500-F923-0248-ACDAA92E7589}"/>
               </a:ext>
             </a:extLst>
           </p:cNvPr>
@@ -15286,7 +15436,7 @@
           <p:cNvPr id="83" name="Elbow Connector 82">
             <a:extLst>
               <a:ext uri="{FF2B5EF4-FFF2-40B4-BE49-F238E27FC236}">
-                <a16:creationId xmlns:a16="http://schemas.microsoft.com/office/drawing/2014/main" id="{0F24C1CF-CB18-9F45-A784-B83E40508CF7}"/>
+                <a16:creationId xmlns:a16="http://schemas.microsoft.com/office/drawing/2014/main" id="{B7643C97-61BB-1E6B-1AC6-21726FDDA661}"/>
               </a:ext>
             </a:extLst>
           </p:cNvPr>
@@ -15331,7 +15481,7 @@
           <p:cNvPr id="90" name="Elbow Connector 89">
             <a:extLst>
               <a:ext uri="{FF2B5EF4-FFF2-40B4-BE49-F238E27FC236}">
-                <a16:creationId xmlns:a16="http://schemas.microsoft.com/office/drawing/2014/main" id="{A41159FF-9E8F-FB44-8E88-8F560F3F3E4B}"/>
+                <a16:creationId xmlns:a16="http://schemas.microsoft.com/office/drawing/2014/main" id="{9EB3EC22-C778-FEF2-683A-EE07FB79478B}"/>
               </a:ext>
             </a:extLst>
           </p:cNvPr>
@@ -15379,7 +15529,7 @@
           <p:cNvPr id="93" name="Elbow Connector 92">
             <a:extLst>
               <a:ext uri="{FF2B5EF4-FFF2-40B4-BE49-F238E27FC236}">
-                <a16:creationId xmlns:a16="http://schemas.microsoft.com/office/drawing/2014/main" id="{CF8CE418-5EB2-3942-94E2-3A107E9D380E}"/>
+                <a16:creationId xmlns:a16="http://schemas.microsoft.com/office/drawing/2014/main" id="{E31E091E-A06C-8C33-BE03-6282A9329A3B}"/>
               </a:ext>
             </a:extLst>
           </p:cNvPr>
@@ -15424,7 +15574,7 @@
           <p:cNvPr id="103" name="Elbow Connector 102">
             <a:extLst>
               <a:ext uri="{FF2B5EF4-FFF2-40B4-BE49-F238E27FC236}">
-                <a16:creationId xmlns:a16="http://schemas.microsoft.com/office/drawing/2014/main" id="{04F129E3-B788-244E-A849-D7B31002492C}"/>
+                <a16:creationId xmlns:a16="http://schemas.microsoft.com/office/drawing/2014/main" id="{E5B0E5F9-1E80-3F07-DA4C-14A7D943BCD8}"/>
               </a:ext>
             </a:extLst>
           </p:cNvPr>
@@ -15469,7 +15619,7 @@
           <p:cNvPr id="110" name="Elbow Connector 109">
             <a:extLst>
               <a:ext uri="{FF2B5EF4-FFF2-40B4-BE49-F238E27FC236}">
-                <a16:creationId xmlns:a16="http://schemas.microsoft.com/office/drawing/2014/main" id="{147BB885-DE33-5445-A31F-38F5A547729F}"/>
+                <a16:creationId xmlns:a16="http://schemas.microsoft.com/office/drawing/2014/main" id="{E42C5BA0-618B-48E9-DCF5-2898F3131BCA}"/>
               </a:ext>
             </a:extLst>
           </p:cNvPr>
@@ -15514,7 +15664,7 @@
           <p:cNvPr id="119" name="Elbow Connector 118">
             <a:extLst>
               <a:ext uri="{FF2B5EF4-FFF2-40B4-BE49-F238E27FC236}">
-                <a16:creationId xmlns:a16="http://schemas.microsoft.com/office/drawing/2014/main" id="{C2E7381A-4900-BC4A-A618-6D7F8821BE3B}"/>
+                <a16:creationId xmlns:a16="http://schemas.microsoft.com/office/drawing/2014/main" id="{98F3EA8B-4FEF-0E10-A8F4-0DFAD02DA083}"/>
               </a:ext>
             </a:extLst>
           </p:cNvPr>
@@ -15559,7 +15709,7 @@
           <p:cNvPr id="140" name="Elbow Connector 139">
             <a:extLst>
               <a:ext uri="{FF2B5EF4-FFF2-40B4-BE49-F238E27FC236}">
-                <a16:creationId xmlns:a16="http://schemas.microsoft.com/office/drawing/2014/main" id="{1B97B39F-CA19-AE43-AB61-06CCF83C43D3}"/>
+                <a16:creationId xmlns:a16="http://schemas.microsoft.com/office/drawing/2014/main" id="{D371C876-572B-9005-9FB8-0338C17831FC}"/>
               </a:ext>
             </a:extLst>
           </p:cNvPr>
@@ -15603,7 +15753,7 @@
           <p:cNvPr id="67" name="Rounded Rectangle 66">
             <a:extLst>
               <a:ext uri="{FF2B5EF4-FFF2-40B4-BE49-F238E27FC236}">
-                <a16:creationId xmlns:a16="http://schemas.microsoft.com/office/drawing/2014/main" id="{29D7D188-8CCC-954E-804B-6611A99A8F65}"/>
+                <a16:creationId xmlns:a16="http://schemas.microsoft.com/office/drawing/2014/main" id="{F5CC94FF-4A4D-C8F9-BE92-092D0A43C2CA}"/>
               </a:ext>
             </a:extLst>
           </p:cNvPr>
@@ -15666,7 +15816,7 @@
           <p:cNvPr id="80" name="Rounded Rectangle 79">
             <a:extLst>
               <a:ext uri="{FF2B5EF4-FFF2-40B4-BE49-F238E27FC236}">
-                <a16:creationId xmlns:a16="http://schemas.microsoft.com/office/drawing/2014/main" id="{3B6E1E3C-F44D-704A-89B0-755B1E344DAD}"/>
+                <a16:creationId xmlns:a16="http://schemas.microsoft.com/office/drawing/2014/main" id="{2337BA3A-8E30-B2B7-743B-6917F46B08D9}"/>
               </a:ext>
             </a:extLst>
           </p:cNvPr>
@@ -15744,7 +15894,7 @@
           <p:cNvPr id="84" name="Rounded Rectangle 83">
             <a:extLst>
               <a:ext uri="{FF2B5EF4-FFF2-40B4-BE49-F238E27FC236}">
-                <a16:creationId xmlns:a16="http://schemas.microsoft.com/office/drawing/2014/main" id="{732FD824-3E7B-7C42-B9D1-19A8004EA454}"/>
+                <a16:creationId xmlns:a16="http://schemas.microsoft.com/office/drawing/2014/main" id="{C21E6211-3EA7-511A-6E87-65B188524EDF}"/>
               </a:ext>
             </a:extLst>
           </p:cNvPr>
@@ -15822,7 +15972,7 @@
           <p:cNvPr id="85" name="Rounded Rectangle 84">
             <a:extLst>
               <a:ext uri="{FF2B5EF4-FFF2-40B4-BE49-F238E27FC236}">
-                <a16:creationId xmlns:a16="http://schemas.microsoft.com/office/drawing/2014/main" id="{97107E32-BFD3-864B-9341-D08C6D27262C}"/>
+                <a16:creationId xmlns:a16="http://schemas.microsoft.com/office/drawing/2014/main" id="{8E7E93D9-4E6A-C6AC-5B48-5AC502625CDE}"/>
               </a:ext>
             </a:extLst>
           </p:cNvPr>
@@ -15900,7 +16050,7 @@
           <p:cNvPr id="87" name="Rounded Rectangle 86">
             <a:extLst>
               <a:ext uri="{FF2B5EF4-FFF2-40B4-BE49-F238E27FC236}">
-                <a16:creationId xmlns:a16="http://schemas.microsoft.com/office/drawing/2014/main" id="{5EB4E5D3-7E8B-324B-B0E6-1457DE77866C}"/>
+                <a16:creationId xmlns:a16="http://schemas.microsoft.com/office/drawing/2014/main" id="{E0180E73-0DA7-308C-D047-0813FF6EF790}"/>
               </a:ext>
             </a:extLst>
           </p:cNvPr>
@@ -15978,7 +16128,7 @@
           <p:cNvPr id="88" name="Rounded Rectangle 87">
             <a:extLst>
               <a:ext uri="{FF2B5EF4-FFF2-40B4-BE49-F238E27FC236}">
-                <a16:creationId xmlns:a16="http://schemas.microsoft.com/office/drawing/2014/main" id="{E19859D4-FC46-0B46-BE5E-0612DAB01C25}"/>
+                <a16:creationId xmlns:a16="http://schemas.microsoft.com/office/drawing/2014/main" id="{4BA9FF2E-0FD0-03AD-5846-21EDB4F689EB}"/>
               </a:ext>
             </a:extLst>
           </p:cNvPr>
@@ -16056,7 +16206,7 @@
           <p:cNvPr id="89" name="Rounded Rectangle 88">
             <a:extLst>
               <a:ext uri="{FF2B5EF4-FFF2-40B4-BE49-F238E27FC236}">
-                <a16:creationId xmlns:a16="http://schemas.microsoft.com/office/drawing/2014/main" id="{0AE35E03-9ECA-7C4E-9C51-08A83073DE3E}"/>
+                <a16:creationId xmlns:a16="http://schemas.microsoft.com/office/drawing/2014/main" id="{A1DF3629-19C8-FBBE-FE74-D2610DC6ACAC}"/>
               </a:ext>
             </a:extLst>
           </p:cNvPr>
@@ -16128,7 +16278,7 @@
           <p:cNvPr id="91" name="Rounded Rectangle 90">
             <a:extLst>
               <a:ext uri="{FF2B5EF4-FFF2-40B4-BE49-F238E27FC236}">
-                <a16:creationId xmlns:a16="http://schemas.microsoft.com/office/drawing/2014/main" id="{C0754F0D-45C9-6849-BC30-4D1A043E3759}"/>
+                <a16:creationId xmlns:a16="http://schemas.microsoft.com/office/drawing/2014/main" id="{7A055727-42D8-FBDC-223F-55A002719161}"/>
               </a:ext>
             </a:extLst>
           </p:cNvPr>
@@ -16200,7 +16350,7 @@
           <p:cNvPr id="92" name="Rounded Rectangle 91">
             <a:extLst>
               <a:ext uri="{FF2B5EF4-FFF2-40B4-BE49-F238E27FC236}">
-                <a16:creationId xmlns:a16="http://schemas.microsoft.com/office/drawing/2014/main" id="{762A3A36-527E-4642-BA48-86C1F0375381}"/>
+                <a16:creationId xmlns:a16="http://schemas.microsoft.com/office/drawing/2014/main" id="{58421633-071E-422A-20DE-89934AC956ED}"/>
               </a:ext>
             </a:extLst>
           </p:cNvPr>
@@ -16278,7 +16428,7 @@
           <p:cNvPr id="94" name="Rounded Rectangle 93">
             <a:extLst>
               <a:ext uri="{FF2B5EF4-FFF2-40B4-BE49-F238E27FC236}">
-                <a16:creationId xmlns:a16="http://schemas.microsoft.com/office/drawing/2014/main" id="{5A78E78D-52D6-8440-B7DC-79ACBEF1AAB7}"/>
+                <a16:creationId xmlns:a16="http://schemas.microsoft.com/office/drawing/2014/main" id="{048C6B25-E63C-5E7A-2E14-A5877DEB3628}"/>
               </a:ext>
             </a:extLst>
           </p:cNvPr>
@@ -16356,7 +16506,7 @@
           <p:cNvPr id="101" name="Rounded Rectangle 100">
             <a:extLst>
               <a:ext uri="{FF2B5EF4-FFF2-40B4-BE49-F238E27FC236}">
-                <a16:creationId xmlns:a16="http://schemas.microsoft.com/office/drawing/2014/main" id="{9B09E6FB-E788-7440-B356-AE60D37F3549}"/>
+                <a16:creationId xmlns:a16="http://schemas.microsoft.com/office/drawing/2014/main" id="{6A2FB963-75EB-0778-8391-B71E6E416409}"/>
               </a:ext>
             </a:extLst>
           </p:cNvPr>
@@ -16434,7 +16584,7 @@
           <p:cNvPr id="102" name="Rounded Rectangle 101">
             <a:extLst>
               <a:ext uri="{FF2B5EF4-FFF2-40B4-BE49-F238E27FC236}">
-                <a16:creationId xmlns:a16="http://schemas.microsoft.com/office/drawing/2014/main" id="{902D2B7A-CC15-6D42-948A-F1ECEEB0FBD9}"/>
+                <a16:creationId xmlns:a16="http://schemas.microsoft.com/office/drawing/2014/main" id="{A49FE5E1-B1BB-9E36-5B36-987E202480D4}"/>
               </a:ext>
             </a:extLst>
           </p:cNvPr>
@@ -16512,7 +16662,7 @@
           <p:cNvPr id="104" name="Rounded Rectangle 103">
             <a:extLst>
               <a:ext uri="{FF2B5EF4-FFF2-40B4-BE49-F238E27FC236}">
-                <a16:creationId xmlns:a16="http://schemas.microsoft.com/office/drawing/2014/main" id="{368A3688-E1C6-8846-A038-A6E332535C8E}"/>
+                <a16:creationId xmlns:a16="http://schemas.microsoft.com/office/drawing/2014/main" id="{1E7881D9-1D66-5E82-1476-18C7960773B5}"/>
               </a:ext>
             </a:extLst>
           </p:cNvPr>
@@ -16590,7 +16740,7 @@
           <p:cNvPr id="106" name="Rounded Rectangle 105">
             <a:extLst>
               <a:ext uri="{FF2B5EF4-FFF2-40B4-BE49-F238E27FC236}">
-                <a16:creationId xmlns:a16="http://schemas.microsoft.com/office/drawing/2014/main" id="{84A8C87C-7F25-234B-B10D-C64B64D1CF8E}"/>
+                <a16:creationId xmlns:a16="http://schemas.microsoft.com/office/drawing/2014/main" id="{34D6D420-1858-AFFB-0603-622FE04D7F2E}"/>
               </a:ext>
             </a:extLst>
           </p:cNvPr>
@@ -16668,7 +16818,7 @@
           <p:cNvPr id="107" name="Rounded Rectangle 106">
             <a:extLst>
               <a:ext uri="{FF2B5EF4-FFF2-40B4-BE49-F238E27FC236}">
-                <a16:creationId xmlns:a16="http://schemas.microsoft.com/office/drawing/2014/main" id="{21C132D3-B377-D547-8957-E3EB59B0D929}"/>
+                <a16:creationId xmlns:a16="http://schemas.microsoft.com/office/drawing/2014/main" id="{3B78CD2C-1F9F-65D6-A3AA-1C7007D37BD6}"/>
               </a:ext>
             </a:extLst>
           </p:cNvPr>
@@ -16746,7 +16896,7 @@
           <p:cNvPr id="111" name="Rounded Rectangle 110">
             <a:extLst>
               <a:ext uri="{FF2B5EF4-FFF2-40B4-BE49-F238E27FC236}">
-                <a16:creationId xmlns:a16="http://schemas.microsoft.com/office/drawing/2014/main" id="{A16ADAE3-096E-2A43-94CA-BF11EA4582F7}"/>
+                <a16:creationId xmlns:a16="http://schemas.microsoft.com/office/drawing/2014/main" id="{34EE743B-D479-0660-9CE3-A83E75E200FB}"/>
               </a:ext>
             </a:extLst>
           </p:cNvPr>
@@ -16818,7 +16968,7 @@
           <p:cNvPr id="112" name="Rounded Rectangle 111">
             <a:extLst>
               <a:ext uri="{FF2B5EF4-FFF2-40B4-BE49-F238E27FC236}">
-                <a16:creationId xmlns:a16="http://schemas.microsoft.com/office/drawing/2014/main" id="{0F18CC42-D329-194C-AE4C-7279609B6F8D}"/>
+                <a16:creationId xmlns:a16="http://schemas.microsoft.com/office/drawing/2014/main" id="{205A93D7-4348-9B0E-7249-5BCBAC601A65}"/>
               </a:ext>
             </a:extLst>
           </p:cNvPr>
@@ -16896,7 +17046,7 @@
           <p:cNvPr id="115" name="Rounded Rectangle 114">
             <a:extLst>
               <a:ext uri="{FF2B5EF4-FFF2-40B4-BE49-F238E27FC236}">
-                <a16:creationId xmlns:a16="http://schemas.microsoft.com/office/drawing/2014/main" id="{D8B42F9D-3061-7341-A6F9-52824B5D0CAD}"/>
+                <a16:creationId xmlns:a16="http://schemas.microsoft.com/office/drawing/2014/main" id="{013CB7DF-88F2-3120-4929-3FA480D38B1B}"/>
               </a:ext>
             </a:extLst>
           </p:cNvPr>
@@ -16974,7 +17124,7 @@
           <p:cNvPr id="120" name="Elbow Connector 119">
             <a:extLst>
               <a:ext uri="{FF2B5EF4-FFF2-40B4-BE49-F238E27FC236}">
-                <a16:creationId xmlns:a16="http://schemas.microsoft.com/office/drawing/2014/main" id="{2C8B8161-A436-CA4D-A82A-F50380633FDC}"/>
+                <a16:creationId xmlns:a16="http://schemas.microsoft.com/office/drawing/2014/main" id="{ECD50146-231B-87D2-4F85-A400F0CEAF30}"/>
               </a:ext>
             </a:extLst>
           </p:cNvPr>
@@ -17019,7 +17169,7 @@
           <p:cNvPr id="134" name="Rounded Rectangle 133">
             <a:extLst>
               <a:ext uri="{FF2B5EF4-FFF2-40B4-BE49-F238E27FC236}">
-                <a16:creationId xmlns:a16="http://schemas.microsoft.com/office/drawing/2014/main" id="{C2F18FBC-41FB-E048-8B47-D40D3CB1ABCE}"/>
+                <a16:creationId xmlns:a16="http://schemas.microsoft.com/office/drawing/2014/main" id="{A78C52CD-7F1A-2855-8A96-B565DDF40C2C}"/>
               </a:ext>
             </a:extLst>
           </p:cNvPr>
@@ -17097,7 +17247,7 @@
           <p:cNvPr id="141" name="Rounded Rectangle 140">
             <a:extLst>
               <a:ext uri="{FF2B5EF4-FFF2-40B4-BE49-F238E27FC236}">
-                <a16:creationId xmlns:a16="http://schemas.microsoft.com/office/drawing/2014/main" id="{6A6C2DC4-474B-BC44-8A77-88BB79C21F6E}"/>
+                <a16:creationId xmlns:a16="http://schemas.microsoft.com/office/drawing/2014/main" id="{A15A1389-F6A2-C92A-A344-8B64188BF31A}"/>
               </a:ext>
             </a:extLst>
           </p:cNvPr>
@@ -17175,7 +17325,7 @@
           <p:cNvPr id="144" name="Rounded Rectangle 143">
             <a:extLst>
               <a:ext uri="{FF2B5EF4-FFF2-40B4-BE49-F238E27FC236}">
-                <a16:creationId xmlns:a16="http://schemas.microsoft.com/office/drawing/2014/main" id="{C69DDB1C-9D98-4F48-8CB0-9B87CD483264}"/>
+                <a16:creationId xmlns:a16="http://schemas.microsoft.com/office/drawing/2014/main" id="{54F58581-0598-1863-FC1F-1EC95E59A1A4}"/>
               </a:ext>
             </a:extLst>
           </p:cNvPr>
@@ -17265,7 +17415,7 @@
           <p:cNvPr id="146" name="Rounded Rectangle 145">
             <a:extLst>
               <a:ext uri="{FF2B5EF4-FFF2-40B4-BE49-F238E27FC236}">
-                <a16:creationId xmlns:a16="http://schemas.microsoft.com/office/drawing/2014/main" id="{F9C81270-91A1-E148-A62E-83A2525F1A4B}"/>
+                <a16:creationId xmlns:a16="http://schemas.microsoft.com/office/drawing/2014/main" id="{69EEFC86-3204-C3CC-D0B5-F901BDA9B113}"/>
               </a:ext>
             </a:extLst>
           </p:cNvPr>
@@ -17343,7 +17493,7 @@
           <p:cNvPr id="148" name="Rounded Rectangle 147">
             <a:extLst>
               <a:ext uri="{FF2B5EF4-FFF2-40B4-BE49-F238E27FC236}">
-                <a16:creationId xmlns:a16="http://schemas.microsoft.com/office/drawing/2014/main" id="{F565E85D-BA72-3A42-9013-1D4C5F740249}"/>
+                <a16:creationId xmlns:a16="http://schemas.microsoft.com/office/drawing/2014/main" id="{E5C4EE2C-F552-88EE-480A-10F6BE922224}"/>
               </a:ext>
             </a:extLst>
           </p:cNvPr>
@@ -17421,7 +17571,7 @@
           <p:cNvPr id="157" name="Rounded Rectangle 156">
             <a:extLst>
               <a:ext uri="{FF2B5EF4-FFF2-40B4-BE49-F238E27FC236}">
-                <a16:creationId xmlns:a16="http://schemas.microsoft.com/office/drawing/2014/main" id="{8C272F1D-0943-EA4F-B3BC-DFD50119FF5D}"/>
+                <a16:creationId xmlns:a16="http://schemas.microsoft.com/office/drawing/2014/main" id="{660A5295-3D1C-4FB1-56D0-40036274442B}"/>
               </a:ext>
             </a:extLst>
           </p:cNvPr>
@@ -17499,7 +17649,7 @@
           <p:cNvPr id="165" name="Rounded Rectangle 164">
             <a:extLst>
               <a:ext uri="{FF2B5EF4-FFF2-40B4-BE49-F238E27FC236}">
-                <a16:creationId xmlns:a16="http://schemas.microsoft.com/office/drawing/2014/main" id="{319C125B-8235-DE4E-AE09-7328BA338C9B}"/>
+                <a16:creationId xmlns:a16="http://schemas.microsoft.com/office/drawing/2014/main" id="{D60E44A0-43C9-DE5C-008A-02E85FB398D6}"/>
               </a:ext>
             </a:extLst>
           </p:cNvPr>
@@ -17577,7 +17727,7 @@
           <p:cNvPr id="166" name="Rounded Rectangle 165">
             <a:extLst>
               <a:ext uri="{FF2B5EF4-FFF2-40B4-BE49-F238E27FC236}">
-                <a16:creationId xmlns:a16="http://schemas.microsoft.com/office/drawing/2014/main" id="{8536B49E-064A-534D-89E4-1B984EB709D7}"/>
+                <a16:creationId xmlns:a16="http://schemas.microsoft.com/office/drawing/2014/main" id="{1997240A-726D-AC43-0791-18A834792C9C}"/>
               </a:ext>
             </a:extLst>
           </p:cNvPr>
@@ -17655,7 +17805,7 @@
           <p:cNvPr id="167" name="Rounded Rectangle 166">
             <a:extLst>
               <a:ext uri="{FF2B5EF4-FFF2-40B4-BE49-F238E27FC236}">
-                <a16:creationId xmlns:a16="http://schemas.microsoft.com/office/drawing/2014/main" id="{7AA22E22-D2C1-B741-9651-BD61435B5C73}"/>
+                <a16:creationId xmlns:a16="http://schemas.microsoft.com/office/drawing/2014/main" id="{8D14D255-C471-D9B4-8B4C-8C4F27518DF4}"/>
               </a:ext>
             </a:extLst>
           </p:cNvPr>
@@ -17733,7 +17883,7 @@
           <p:cNvPr id="168" name="Rounded Rectangle 167">
             <a:extLst>
               <a:ext uri="{FF2B5EF4-FFF2-40B4-BE49-F238E27FC236}">
-                <a16:creationId xmlns:a16="http://schemas.microsoft.com/office/drawing/2014/main" id="{BE0BE30A-E4BF-3343-81C0-5762FE818E1A}"/>
+                <a16:creationId xmlns:a16="http://schemas.microsoft.com/office/drawing/2014/main" id="{E82D3EFD-9682-1FD0-012F-C4CB173239C5}"/>
               </a:ext>
             </a:extLst>
           </p:cNvPr>
@@ -17811,7 +17961,7 @@
           <p:cNvPr id="176" name="Rounded Rectangle 175">
             <a:extLst>
               <a:ext uri="{FF2B5EF4-FFF2-40B4-BE49-F238E27FC236}">
-                <a16:creationId xmlns:a16="http://schemas.microsoft.com/office/drawing/2014/main" id="{48A5A8C6-D27C-7845-8D73-D551E4D936AE}"/>
+                <a16:creationId xmlns:a16="http://schemas.microsoft.com/office/drawing/2014/main" id="{49DD6A17-A11F-A26C-20B5-A5784627BABB}"/>
               </a:ext>
             </a:extLst>
           </p:cNvPr>
@@ -17889,7 +18039,7 @@
           <p:cNvPr id="177" name="Rounded Rectangle 176">
             <a:extLst>
               <a:ext uri="{FF2B5EF4-FFF2-40B4-BE49-F238E27FC236}">
-                <a16:creationId xmlns:a16="http://schemas.microsoft.com/office/drawing/2014/main" id="{D99C8058-1E01-8049-A6B5-2C1D4B204798}"/>
+                <a16:creationId xmlns:a16="http://schemas.microsoft.com/office/drawing/2014/main" id="{D6D66BB8-12FD-8330-FCF0-8F47A7605A64}"/>
               </a:ext>
             </a:extLst>
           </p:cNvPr>
@@ -17967,7 +18117,7 @@
           <p:cNvPr id="187" name="Elbow Connector 186">
             <a:extLst>
               <a:ext uri="{FF2B5EF4-FFF2-40B4-BE49-F238E27FC236}">
-                <a16:creationId xmlns:a16="http://schemas.microsoft.com/office/drawing/2014/main" id="{43489651-E858-2D42-96A7-B6BE4B5D1DB1}"/>
+                <a16:creationId xmlns:a16="http://schemas.microsoft.com/office/drawing/2014/main" id="{DBE4363D-7038-D1AB-124C-7A41E2E753D4}"/>
               </a:ext>
             </a:extLst>
           </p:cNvPr>
@@ -18013,7 +18163,7 @@
           <p:cNvPr id="207" name="Elbow Connector 206">
             <a:extLst>
               <a:ext uri="{FF2B5EF4-FFF2-40B4-BE49-F238E27FC236}">
-                <a16:creationId xmlns:a16="http://schemas.microsoft.com/office/drawing/2014/main" id="{256AC07A-A1E1-8546-9393-6350BB5A3079}"/>
+                <a16:creationId xmlns:a16="http://schemas.microsoft.com/office/drawing/2014/main" id="{B925DC1E-F465-16FB-6E40-DEF05ADA2637}"/>
               </a:ext>
             </a:extLst>
           </p:cNvPr>
@@ -18058,7 +18208,7 @@
           <p:cNvPr id="230" name="Elbow Connector 229">
             <a:extLst>
               <a:ext uri="{FF2B5EF4-FFF2-40B4-BE49-F238E27FC236}">
-                <a16:creationId xmlns:a16="http://schemas.microsoft.com/office/drawing/2014/main" id="{228A3DD1-6395-DE4B-925F-1D655D5FD11A}"/>
+                <a16:creationId xmlns:a16="http://schemas.microsoft.com/office/drawing/2014/main" id="{7B2B0D47-D78A-C2AF-67CD-2D456499E0F6}"/>
               </a:ext>
             </a:extLst>
           </p:cNvPr>
@@ -18103,7 +18253,7 @@
           <p:cNvPr id="283" name="Elbow Connector 282">
             <a:extLst>
               <a:ext uri="{FF2B5EF4-FFF2-40B4-BE49-F238E27FC236}">
-                <a16:creationId xmlns:a16="http://schemas.microsoft.com/office/drawing/2014/main" id="{F65012B1-8420-2642-8CC7-DE808C5A279C}"/>
+                <a16:creationId xmlns:a16="http://schemas.microsoft.com/office/drawing/2014/main" id="{6C1A865D-06DB-1B74-3247-89845A674C4B}"/>
               </a:ext>
             </a:extLst>
           </p:cNvPr>
@@ -18142,56 +18292,12 @@
           </a:fontRef>
         </p:style>
       </p:cxnSp>
-      <p:cxnSp>
-        <p:nvCxnSpPr>
-          <p:cNvPr id="318" name="Elbow Connector 317">
-            <a:extLst>
-              <a:ext uri="{FF2B5EF4-FFF2-40B4-BE49-F238E27FC236}">
-                <a16:creationId xmlns:a16="http://schemas.microsoft.com/office/drawing/2014/main" id="{B329DC1F-A4D4-5146-8CF7-B2ADF5E81ED5}"/>
-              </a:ext>
-            </a:extLst>
-          </p:cNvPr>
-          <p:cNvCxnSpPr>
-            <a:cxnSpLocks/>
-          </p:cNvCxnSpPr>
-          <p:nvPr/>
-        </p:nvCxnSpPr>
-        <p:spPr>
-          <a:xfrm>
-            <a:off x="10945940" y="7034570"/>
-            <a:ext cx="407276" cy="3022"/>
-          </a:xfrm>
-          <a:prstGeom prst="bentConnector3">
-            <a:avLst>
-              <a:gd name="adj1" fmla="val 50000"/>
-            </a:avLst>
-          </a:prstGeom>
-          <a:ln>
-            <a:prstDash val="dash"/>
-            <a:tailEnd type="triangle"/>
-          </a:ln>
-        </p:spPr>
-        <p:style>
-          <a:lnRef idx="1">
-            <a:schemeClr val="accent1"/>
-          </a:lnRef>
-          <a:fillRef idx="0">
-            <a:schemeClr val="accent1"/>
-          </a:fillRef>
-          <a:effectRef idx="0">
-            <a:schemeClr val="accent1"/>
-          </a:effectRef>
-          <a:fontRef idx="minor">
-            <a:schemeClr val="tx1"/>
-          </a:fontRef>
-        </p:style>
-      </p:cxnSp>
       <p:sp>
         <p:nvSpPr>
           <p:cNvPr id="321" name="TextBox 320">
             <a:extLst>
               <a:ext uri="{FF2B5EF4-FFF2-40B4-BE49-F238E27FC236}">
-                <a16:creationId xmlns:a16="http://schemas.microsoft.com/office/drawing/2014/main" id="{FC347B98-7402-7F40-9733-A0912DA7C3C1}"/>
+                <a16:creationId xmlns:a16="http://schemas.microsoft.com/office/drawing/2014/main" id="{BF1C883E-FF11-4F14-F4A4-AE57F517B7C2}"/>
               </a:ext>
             </a:extLst>
           </p:cNvPr>
@@ -18201,7 +18307,7 @@
         <p:spPr>
           <a:xfrm>
             <a:off x="11402876" y="6910655"/>
-            <a:ext cx="798617" cy="646331"/>
+            <a:ext cx="1079142" cy="646331"/>
           </a:xfrm>
           <a:prstGeom prst="rect">
             <a:avLst/>
@@ -18219,7 +18325,7 @@
                 <a:latin typeface="Arial" panose="020B0604020202020204" pitchFamily="34" charset="0"/>
                 <a:cs typeface="Arial" panose="020B0604020202020204" pitchFamily="34" charset="0"/>
               </a:rPr>
-              <a:t>data</a:t>
+              <a:t>flow</a:t>
             </a:r>
             <a:r>
               <a:rPr lang="de-DE" sz="1200" dirty="0">
@@ -18233,7 +18339,7 @@
                 <a:latin typeface="Arial" panose="020B0604020202020204" pitchFamily="34" charset="0"/>
                 <a:cs typeface="Arial" panose="020B0604020202020204" pitchFamily="34" charset="0"/>
               </a:rPr>
-              <a:t>flow</a:t>
+              <a:t>direction</a:t>
             </a:r>
             <a:br>
               <a:rPr lang="de-DE" sz="1200" dirty="0">
@@ -18247,13 +18353,6 @@
                 <a:cs typeface="Arial" panose="020B0604020202020204" pitchFamily="34" charset="0"/>
               </a:rPr>
             </a:br>
-            <a:r>
-              <a:rPr lang="de-DE" sz="1200" dirty="0" err="1">
-                <a:latin typeface="Arial" panose="020B0604020202020204" pitchFamily="34" charset="0"/>
-                <a:cs typeface="Arial" panose="020B0604020202020204" pitchFamily="34" charset="0"/>
-              </a:rPr>
-              <a:t>includes</a:t>
-            </a:r>
             <a:endParaRPr lang="de-DE" sz="1200" dirty="0">
               <a:latin typeface="Courier" pitchFamily="2" charset="0"/>
               <a:cs typeface="Arial" panose="020B0604020202020204" pitchFamily="34" charset="0"/>
@@ -18266,7 +18365,7 @@
           <p:cNvPr id="322" name="Elbow Connector 321">
             <a:extLst>
               <a:ext uri="{FF2B5EF4-FFF2-40B4-BE49-F238E27FC236}">
-                <a16:creationId xmlns:a16="http://schemas.microsoft.com/office/drawing/2014/main" id="{A934EA42-B256-FC4E-8968-D71FDB11AA16}"/>
+                <a16:creationId xmlns:a16="http://schemas.microsoft.com/office/drawing/2014/main" id="{C4E3BAB2-79DB-6CB2-0126-1B3587944762}"/>
               </a:ext>
             </a:extLst>
           </p:cNvPr>
@@ -18277,12 +18376,12 @@
         </p:nvCxnSpPr>
         <p:spPr>
           <a:xfrm>
-            <a:off x="10945940" y="7437458"/>
-            <a:ext cx="407276" cy="3022"/>
+            <a:off x="10968667" y="7099892"/>
+            <a:ext cx="407276" cy="0"/>
           </a:xfrm>
           <a:prstGeom prst="bentConnector3">
             <a:avLst>
-              <a:gd name="adj1" fmla="val 50000"/>
+              <a:gd name="adj1" fmla="val 64967"/>
             </a:avLst>
           </a:prstGeom>
           <a:ln>
@@ -18310,7 +18409,7 @@
           <p:cNvPr id="4" name="Rounded Rectangle 3">
             <a:extLst>
               <a:ext uri="{FF2B5EF4-FFF2-40B4-BE49-F238E27FC236}">
-                <a16:creationId xmlns:a16="http://schemas.microsoft.com/office/drawing/2014/main" id="{CE87A59E-1D64-3F63-9A6C-ABB405326E10}"/>
+                <a16:creationId xmlns:a16="http://schemas.microsoft.com/office/drawing/2014/main" id="{4753AA2D-900B-4711-F71B-2DD619500566}"/>
               </a:ext>
             </a:extLst>
           </p:cNvPr>
@@ -18388,7 +18487,7 @@
           <p:cNvPr id="6" name="Rounded Rectangle 5">
             <a:extLst>
               <a:ext uri="{FF2B5EF4-FFF2-40B4-BE49-F238E27FC236}">
-                <a16:creationId xmlns:a16="http://schemas.microsoft.com/office/drawing/2014/main" id="{6FFA7931-F2F9-8EA3-375A-7C04E7DFED3C}"/>
+                <a16:creationId xmlns:a16="http://schemas.microsoft.com/office/drawing/2014/main" id="{D8EFADAD-C713-C67F-76D2-4363D6E11FCF}"/>
               </a:ext>
             </a:extLst>
           </p:cNvPr>
@@ -18460,7 +18559,7 @@
           <p:cNvPr id="2" name="TextBox 1">
             <a:extLst>
               <a:ext uri="{FF2B5EF4-FFF2-40B4-BE49-F238E27FC236}">
-                <a16:creationId xmlns:a16="http://schemas.microsoft.com/office/drawing/2014/main" id="{C66F64B8-6A07-59ED-97FC-F372E16B24A8}"/>
+                <a16:creationId xmlns:a16="http://schemas.microsoft.com/office/drawing/2014/main" id="{B866C100-2E7B-57B8-F3ED-8F6D24692BDF}"/>
               </a:ext>
             </a:extLst>
           </p:cNvPr>
@@ -18470,7 +18569,7 @@
         <p:spPr>
           <a:xfrm>
             <a:off x="380116" y="260967"/>
-            <a:ext cx="4789076" cy="461665"/>
+            <a:ext cx="10632734" cy="461665"/>
           </a:xfrm>
           <a:prstGeom prst="rect">
             <a:avLst/>
@@ -18488,7 +18587,7 @@
                 <a:latin typeface="Courier New" panose="02070309020205020404" pitchFamily="49" charset="0"/>
                 <a:cs typeface="Courier New" panose="02070309020205020404" pitchFamily="49" charset="0"/>
               </a:rPr>
-              <a:t>AngstromCube/green</a:t>
+              <a:t>AngstromCube/green		DataFlow</a:t>
             </a:r>
           </a:p>
         </p:txBody>
@@ -18498,7 +18597,7 @@
           <p:cNvPr id="48" name="Group 47">
             <a:extLst>
               <a:ext uri="{FF2B5EF4-FFF2-40B4-BE49-F238E27FC236}">
-                <a16:creationId xmlns:a16="http://schemas.microsoft.com/office/drawing/2014/main" id="{730DACA5-B497-276A-B32D-E9D986767DF6}"/>
+                <a16:creationId xmlns:a16="http://schemas.microsoft.com/office/drawing/2014/main" id="{F9F198F1-8D5C-51D1-E54D-42A5DD7BDFE4}"/>
               </a:ext>
             </a:extLst>
           </p:cNvPr>
@@ -18518,7 +18617,7 @@
             <p:cNvPr id="10" name="Picture 9">
               <a:extLst>
                 <a:ext uri="{FF2B5EF4-FFF2-40B4-BE49-F238E27FC236}">
-                  <a16:creationId xmlns:a16="http://schemas.microsoft.com/office/drawing/2014/main" id="{76DAF4E8-1107-0B19-C3B4-DB6A04BB022C}"/>
+                  <a16:creationId xmlns:a16="http://schemas.microsoft.com/office/drawing/2014/main" id="{FD7BBB60-BFF5-158C-D8F6-2854FCC5B2F6}"/>
                 </a:ext>
               </a:extLst>
             </p:cNvPr>
@@ -18550,7 +18649,7 @@
             <p:cNvPr id="13" name="Group 12">
               <a:extLst>
                 <a:ext uri="{FF2B5EF4-FFF2-40B4-BE49-F238E27FC236}">
-                  <a16:creationId xmlns:a16="http://schemas.microsoft.com/office/drawing/2014/main" id="{9C8B5DBB-CA45-3D56-4365-B5146B505C0B}"/>
+                  <a16:creationId xmlns:a16="http://schemas.microsoft.com/office/drawing/2014/main" id="{F0EA06D1-CC37-B865-D738-3895A7C44862}"/>
                 </a:ext>
               </a:extLst>
             </p:cNvPr>
@@ -18560,9 +18659,9 @@
           <p:grpSpPr>
             <a:xfrm>
               <a:off x="7200000" y="720000"/>
-              <a:ext cx="2767964" cy="540000"/>
+              <a:ext cx="2312519" cy="540000"/>
               <a:chOff x="6588961" y="855052"/>
-              <a:chExt cx="2767964" cy="540000"/>
+              <a:chExt cx="2312519" cy="540000"/>
             </a:xfrm>
           </p:grpSpPr>
           <p:sp>
@@ -18570,7 +18669,7 @@
               <p:cNvPr id="15" name="Rounded Rectangle 14">
                 <a:extLst>
                   <a:ext uri="{FF2B5EF4-FFF2-40B4-BE49-F238E27FC236}">
-                    <a16:creationId xmlns:a16="http://schemas.microsoft.com/office/drawing/2014/main" id="{B7263798-AC45-4C30-4B92-0360FD57E382}"/>
+                    <a16:creationId xmlns:a16="http://schemas.microsoft.com/office/drawing/2014/main" id="{7ED03CF7-54C2-AD9D-9709-9DC45D479EFD}"/>
                   </a:ext>
                 </a:extLst>
               </p:cNvPr>
@@ -18631,7 +18730,7 @@
               <p:cNvPr id="24" name="TextBox 23">
                 <a:extLst>
                   <a:ext uri="{FF2B5EF4-FFF2-40B4-BE49-F238E27FC236}">
-                    <a16:creationId xmlns:a16="http://schemas.microsoft.com/office/drawing/2014/main" id="{CF189AE7-8E19-9E63-FCAB-24DA952A3826}"/>
+                    <a16:creationId xmlns:a16="http://schemas.microsoft.com/office/drawing/2014/main" id="{39E37BEA-7A9E-2C12-87F1-F8209B05E307}"/>
                   </a:ext>
                 </a:extLst>
               </p:cNvPr>
@@ -18641,7 +18740,7 @@
             <p:spPr>
               <a:xfrm>
                 <a:off x="7966801" y="886855"/>
-                <a:ext cx="1390124" cy="276999"/>
+                <a:ext cx="934679" cy="276999"/>
               </a:xfrm>
               <a:prstGeom prst="rect">
                 <a:avLst/>
@@ -18656,21 +18755,21 @@
               <a:p>
                 <a:r>
                   <a:rPr lang="de-DE" sz="1200" dirty="0">
-                    <a:latin typeface="Courier New" panose="02070309020205020404" pitchFamily="49" charset="0"/>
-                    <a:cs typeface="Courier New" panose="02070309020205020404" pitchFamily="49" charset="0"/>
+                    <a:latin typeface="Calibri" panose="020F0502020204030204" pitchFamily="34" charset="0"/>
+                    <a:cs typeface="Calibri" panose="020F0502020204030204" pitchFamily="34" charset="0"/>
                   </a:rPr>
                   <a:t>+</a:t>
                 </a:r>
                 <a:r>
                   <a:rPr lang="de-DE" sz="1200" dirty="0" err="1">
-                    <a:latin typeface="Courier New" panose="02070309020205020404" pitchFamily="49" charset="0"/>
-                    <a:cs typeface="Courier New" panose="02070309020205020404" pitchFamily="49" charset="0"/>
+                    <a:latin typeface="Calibri" panose="020F0502020204030204" pitchFamily="34" charset="0"/>
+                    <a:cs typeface="Calibri" panose="020F0502020204030204" pitchFamily="34" charset="0"/>
                   </a:rPr>
                   <a:t>control.file</a:t>
                 </a:r>
                 <a:endParaRPr lang="de-DE" sz="1200" dirty="0">
-                  <a:latin typeface="Courier New" panose="02070309020205020404" pitchFamily="49" charset="0"/>
-                  <a:cs typeface="Courier New" panose="02070309020205020404" pitchFamily="49" charset="0"/>
+                  <a:latin typeface="Calibri" panose="020F0502020204030204" pitchFamily="34" charset="0"/>
+                  <a:cs typeface="Calibri" panose="020F0502020204030204" pitchFamily="34" charset="0"/>
                 </a:endParaRPr>
               </a:p>
             </p:txBody>
@@ -18681,7 +18780,7 @@
             <p:cNvPr id="30" name="Elbow Connector 29">
               <a:extLst>
                 <a:ext uri="{FF2B5EF4-FFF2-40B4-BE49-F238E27FC236}">
-                  <a16:creationId xmlns:a16="http://schemas.microsoft.com/office/drawing/2014/main" id="{0737D283-BF7C-DE0F-3F78-5D9AD99A9D50}"/>
+                  <a16:creationId xmlns:a16="http://schemas.microsoft.com/office/drawing/2014/main" id="{2775C3DD-7532-BC8E-EFAE-BA1BBEC0FAE5}"/>
                 </a:ext>
               </a:extLst>
             </p:cNvPr>
@@ -18727,7 +18826,7 @@
             <p:cNvPr id="32" name="Rounded Rectangle 31">
               <a:extLst>
                 <a:ext uri="{FF2B5EF4-FFF2-40B4-BE49-F238E27FC236}">
-                  <a16:creationId xmlns:a16="http://schemas.microsoft.com/office/drawing/2014/main" id="{7CBAEC05-E62A-D4ED-727B-F3921406CBB1}"/>
+                  <a16:creationId xmlns:a16="http://schemas.microsoft.com/office/drawing/2014/main" id="{0F9EEC99-9C7B-62EB-E672-BF5DE636A0FA}"/>
                 </a:ext>
               </a:extLst>
             </p:cNvPr>
@@ -18805,7 +18904,7 @@
             <p:cNvPr id="45" name="Rounded Rectangle 44">
               <a:extLst>
                 <a:ext uri="{FF2B5EF4-FFF2-40B4-BE49-F238E27FC236}">
-                  <a16:creationId xmlns:a16="http://schemas.microsoft.com/office/drawing/2014/main" id="{06020707-FF03-D270-1760-812FC7136FC0}"/>
+                  <a16:creationId xmlns:a16="http://schemas.microsoft.com/office/drawing/2014/main" id="{020E1937-EC86-921E-0BBA-F40DCD90EF9E}"/>
                 </a:ext>
               </a:extLst>
             </p:cNvPr>
@@ -18883,7 +18982,7 @@
             <p:cNvPr id="46" name="Rounded Rectangle 45">
               <a:extLst>
                 <a:ext uri="{FF2B5EF4-FFF2-40B4-BE49-F238E27FC236}">
-                  <a16:creationId xmlns:a16="http://schemas.microsoft.com/office/drawing/2014/main" id="{640C8E47-FD70-A066-8FB4-8B9F289EAE6C}"/>
+                  <a16:creationId xmlns:a16="http://schemas.microsoft.com/office/drawing/2014/main" id="{8FE97BAB-BBEE-20D4-6296-D075AC0E2F70}"/>
                 </a:ext>
               </a:extLst>
             </p:cNvPr>
@@ -18962,7 +19061,7 @@
           <p:cNvPr id="58" name="Elbow Connector 57">
             <a:extLst>
               <a:ext uri="{FF2B5EF4-FFF2-40B4-BE49-F238E27FC236}">
-                <a16:creationId xmlns:a16="http://schemas.microsoft.com/office/drawing/2014/main" id="{73B1B3EF-6924-15D8-C2B5-718B4CF877F3}"/>
+                <a16:creationId xmlns:a16="http://schemas.microsoft.com/office/drawing/2014/main" id="{352682EF-E537-8DC3-B7F7-43AC8F125CFD}"/>
               </a:ext>
             </a:extLst>
           </p:cNvPr>
@@ -19008,7 +19107,7 @@
           <p:cNvPr id="63" name="Rounded Rectangle 62">
             <a:extLst>
               <a:ext uri="{FF2B5EF4-FFF2-40B4-BE49-F238E27FC236}">
-                <a16:creationId xmlns:a16="http://schemas.microsoft.com/office/drawing/2014/main" id="{660DEC48-08E5-13AC-D04B-533A239FB102}"/>
+                <a16:creationId xmlns:a16="http://schemas.microsoft.com/office/drawing/2014/main" id="{FAF6D495-0D45-29FA-0DC2-D4661C96662A}"/>
               </a:ext>
             </a:extLst>
           </p:cNvPr>
@@ -19086,7 +19185,7 @@
           <p:cNvPr id="451" name="Elbow Connector 450">
             <a:extLst>
               <a:ext uri="{FF2B5EF4-FFF2-40B4-BE49-F238E27FC236}">
-                <a16:creationId xmlns:a16="http://schemas.microsoft.com/office/drawing/2014/main" id="{87D6577E-73D8-32B5-3F8D-839427D2DEC6}"/>
+                <a16:creationId xmlns:a16="http://schemas.microsoft.com/office/drawing/2014/main" id="{8C7EDE67-3D3D-495C-4CE6-512A2B6F650E}"/>
               </a:ext>
             </a:extLst>
           </p:cNvPr>
@@ -19132,7 +19231,7 @@
           <p:cNvPr id="454" name="Rounded Rectangle 453">
             <a:extLst>
               <a:ext uri="{FF2B5EF4-FFF2-40B4-BE49-F238E27FC236}">
-                <a16:creationId xmlns:a16="http://schemas.microsoft.com/office/drawing/2014/main" id="{224930B3-5ABB-3D23-912E-44F959F453FB}"/>
+                <a16:creationId xmlns:a16="http://schemas.microsoft.com/office/drawing/2014/main" id="{F218CC7F-E6DE-25F0-294A-B9215FDCB684}"/>
               </a:ext>
             </a:extLst>
           </p:cNvPr>
@@ -19204,7 +19303,7 @@
           <p:cNvPr id="455" name="Rounded Rectangle 454">
             <a:extLst>
               <a:ext uri="{FF2B5EF4-FFF2-40B4-BE49-F238E27FC236}">
-                <a16:creationId xmlns:a16="http://schemas.microsoft.com/office/drawing/2014/main" id="{BEA8D880-290B-F09F-948C-9F82A81EE711}"/>
+                <a16:creationId xmlns:a16="http://schemas.microsoft.com/office/drawing/2014/main" id="{3B4A3D0E-CC76-05A8-18FC-8B2A1D34C9AB}"/>
               </a:ext>
             </a:extLst>
           </p:cNvPr>
@@ -19282,7 +19381,7 @@
           <p:cNvPr id="456" name="Elbow Connector 455">
             <a:extLst>
               <a:ext uri="{FF2B5EF4-FFF2-40B4-BE49-F238E27FC236}">
-                <a16:creationId xmlns:a16="http://schemas.microsoft.com/office/drawing/2014/main" id="{352E299C-B010-75AA-CEAD-54E87F727C7A}"/>
+                <a16:creationId xmlns:a16="http://schemas.microsoft.com/office/drawing/2014/main" id="{5D168BDA-53DB-4705-B56C-1A23F6532E46}"/>
               </a:ext>
             </a:extLst>
           </p:cNvPr>
@@ -19328,7 +19427,7 @@
           <p:cNvPr id="459" name="Rounded Rectangle 458">
             <a:extLst>
               <a:ext uri="{FF2B5EF4-FFF2-40B4-BE49-F238E27FC236}">
-                <a16:creationId xmlns:a16="http://schemas.microsoft.com/office/drawing/2014/main" id="{CEA284CE-4400-4AA7-70F4-57B5C2936B96}"/>
+                <a16:creationId xmlns:a16="http://schemas.microsoft.com/office/drawing/2014/main" id="{6D3227B6-71BA-0A76-A604-E2DF8E02E36B}"/>
               </a:ext>
             </a:extLst>
           </p:cNvPr>
@@ -19406,7 +19505,7 @@
           <p:cNvPr id="460" name="Rounded Rectangle 459">
             <a:extLst>
               <a:ext uri="{FF2B5EF4-FFF2-40B4-BE49-F238E27FC236}">
-                <a16:creationId xmlns:a16="http://schemas.microsoft.com/office/drawing/2014/main" id="{74FF2459-25A8-0544-8364-406924A3B7C2}"/>
+                <a16:creationId xmlns:a16="http://schemas.microsoft.com/office/drawing/2014/main" id="{F119444A-1F77-38EC-C1DD-9BA6C041ABD8}"/>
               </a:ext>
             </a:extLst>
           </p:cNvPr>
@@ -19478,7 +19577,7 @@
           <p:cNvPr id="472" name="Elbow Connector 471">
             <a:extLst>
               <a:ext uri="{FF2B5EF4-FFF2-40B4-BE49-F238E27FC236}">
-                <a16:creationId xmlns:a16="http://schemas.microsoft.com/office/drawing/2014/main" id="{9ECC91DC-7E4E-583C-E6CB-F10FFB23ABAE}"/>
+                <a16:creationId xmlns:a16="http://schemas.microsoft.com/office/drawing/2014/main" id="{71F13B36-079D-AB38-7187-6C2D23ACD3F9}"/>
               </a:ext>
             </a:extLst>
           </p:cNvPr>
@@ -19525,7 +19624,7 @@
           <p:cNvPr id="490" name="Elbow Connector 489">
             <a:extLst>
               <a:ext uri="{FF2B5EF4-FFF2-40B4-BE49-F238E27FC236}">
-                <a16:creationId xmlns:a16="http://schemas.microsoft.com/office/drawing/2014/main" id="{D391A121-F83F-6583-5AF6-10B486F0128D}"/>
+                <a16:creationId xmlns:a16="http://schemas.microsoft.com/office/drawing/2014/main" id="{E70396B4-3772-0D21-BD56-7B247040997B}"/>
               </a:ext>
             </a:extLst>
           </p:cNvPr>
@@ -19573,7 +19672,7 @@
           <p:cNvPr id="498" name="Elbow Connector 497">
             <a:extLst>
               <a:ext uri="{FF2B5EF4-FFF2-40B4-BE49-F238E27FC236}">
-                <a16:creationId xmlns:a16="http://schemas.microsoft.com/office/drawing/2014/main" id="{EDDDF8D8-3785-5F87-95C0-7C4642A3CE3B}"/>
+                <a16:creationId xmlns:a16="http://schemas.microsoft.com/office/drawing/2014/main" id="{30F7B016-C331-0456-E209-08F2E4AD89A6}"/>
               </a:ext>
             </a:extLst>
           </p:cNvPr>
@@ -19619,7 +19718,7 @@
           <p:cNvPr id="503" name="Elbow Connector 502">
             <a:extLst>
               <a:ext uri="{FF2B5EF4-FFF2-40B4-BE49-F238E27FC236}">
-                <a16:creationId xmlns:a16="http://schemas.microsoft.com/office/drawing/2014/main" id="{3773A7D1-84D0-E07C-AA69-F641265EA18D}"/>
+                <a16:creationId xmlns:a16="http://schemas.microsoft.com/office/drawing/2014/main" id="{030B0079-B1EF-D79D-5167-15347D25E7A5}"/>
               </a:ext>
             </a:extLst>
           </p:cNvPr>
@@ -19663,7 +19762,7 @@
     </p:spTree>
     <p:extLst>
       <p:ext uri="{BB962C8B-B14F-4D97-AF65-F5344CB8AC3E}">
-        <p14:creationId xmlns:p14="http://schemas.microsoft.com/office/powerpoint/2010/main" val="421917412"/>
+        <p14:creationId xmlns:p14="http://schemas.microsoft.com/office/powerpoint/2010/main" val="4247466196"/>
       </p:ext>
     </p:extLst>
   </p:cSld>

</xml_diff>